<commit_message>
Correct developer draft claims and test the actual document example
</commit_message>
<xml_diff>
--- a/docs/presentation/nanolang-developer-overview.pptx
+++ b/docs/presentation/nanolang-developer-overview.pptx
@@ -522,7 +522,7 @@
           </a:p>
           <a:p>
             <a:r>
-              <a:t>I am a language and a secure runtime. I do not claim a kernel.</a:t>
+              <a:t>I am a language with a runtime under development. This local draft is not a release or a production-isolation claim.</a:t>
             </a:r>
           </a:p>
           <a:p>
@@ -597,12 +597,22 @@
           <a:lstStyle/>
           <a:p>
             <a:r>
-              <a:t>Authority: CONTRIBUTING.md and the current test suites, counted at the v4.0.0 tag.</a:t>
-            </a:r>
-          </a:p>
-          <a:p>
-            <a:r>
-              <a:t>make test-verify-all-programs additionally verifies every program in tests/, because compiling is not verifying.</a:t>
+              <a:t>Authority: CONTRIBUTING.md, docs/CANONICAL_STYLE.md, tests/test_language_claims.py and examples/gcd.nano.</a:t>
+            </a:r>
+          </a:p>
+          <a:p>
+            <a:r>
+              <a:t>CPU exemptions include externs, main, generated lambdas and functions using extern calls. Explicit foreign-call shadows still run.</a:t>
+            </a:r>
+          </a:p>
+          <a:p>
+            <a:r>
+              <a:t>All three drivers select dependency shadows by default; --root-shadows-only opts out. Test processes have deadlines, not sandboxing.</a:t>
+            </a:r>
+          </a:p>
+          <a:p>
+            <a:r>
+              <a:t>I exercise nonnegative and zero gcd inputs here. These assertions are not a theorem for all integers.</a:t>
             </a:r>
           </a:p>
         </p:txBody>
@@ -1142,17 +1152,12 @@
           </a:p>
           <a:p>
             <a:r>
-              <a:t>This slide carries the thesis. Everything after it is a mechanism serving this claim,</a:t>
-            </a:r>
-          </a:p>
-          <a:p>
-            <a:r>
-              <a:t>and a reader who does not accept it here will not care about the module format.</a:t>
-            </a:r>
-          </a:p>
-          <a:p>
-            <a:r>
-              <a:t>PROOF is not decoration: a function without a shadow test does not compile.</a:t>
+              <a:t>My project policy requires useful shadows. My compiler normally warns about missing tests, with documented exemptions.</a:t>
+            </a:r>
+          </a:p>
+          <a:p>
+            <a:r>
+              <a:t>A shadow tests its assertions; it does not prove every input. Compiler acceptance is not proof of correctness.</a:t>
             </a:r>
           </a:p>
         </p:txBody>
@@ -1452,7 +1457,12 @@
           </a:p>
           <a:p>
             <a:r>
-              <a:t>Every call now carries its signature, so a module is provable before it is linked.</a:t>
+              <a:t>Imported signatures are declarations, not proof of foreign behavior. My abstract reference counter does not identify objects.</a:t>
+            </a:r>
+          </a:p>
+          <a:p>
+            <a:r>
+              <a:t>Formal NanoCore theorems and compiler correspondence are separate boundaries; see formal/README.md and docs/ROADMAP.md.</a:t>
             </a:r>
           </a:p>
         </p:txBody>
@@ -1607,7 +1617,7 @@
           </a:p>
           <a:p>
             <a:r>
-              <a:t>784 lines of fuzz and malformed-input tests were added in 4.0 across the six surfaces named here.</a:t>
+              <a:t>I distinguish deterministic malformed-input testing, seed replay and mutation campaigns.</a:t>
             </a:r>
           </a:p>
           <a:p>
@@ -1692,7 +1702,7 @@
           </a:p>
           <a:p>
             <a:r>
-              <a:t>VM_CASE and VM_NEXT are the only difference, so the two strategies cannot drift in what an instruction does.</a:t>
+              <a:t>Shared handler bodies reduce duplication; execution equivalence still needs tests.</a:t>
             </a:r>
           </a:p>
           <a:p>
@@ -4842,7 +4852,7 @@
                 </a:solidFill>
                 <a:latin typeface="Arial"/>
               </a:rPr>
-              <a:t>NANOLANG 4.5</a:t>
+              <a:t>NANOLANG 5.0 DRAFT</a:t>
             </a:r>
           </a:p>
         </p:txBody>
@@ -4943,7 +4953,7 @@
                 </a:solidFill>
                 <a:latin typeface="Arial"/>
               </a:rPr>
-              <a:t>A developer's view of my syntax, compiler, NanoISA, and the secure runtime I host on POSIX.</a:t>
+              <a:t>A developer's view of my syntax, compiler, NanoISA, and runtime foundations on POSIX.</a:t>
             </a:r>
           </a:p>
         </p:txBody>
@@ -5072,7 +5082,7 @@
                 </a:solidFill>
                 <a:latin typeface="Arial"/>
               </a:rPr>
-              <a:t>Every function carries a shadow test.</a:t>
+              <a:t>I require useful shadows by project policy.</a:t>
             </a:r>
           </a:p>
         </p:txBody>
@@ -5106,7 +5116,7 @@
                 </a:solidFill>
                 <a:latin typeface="Arial"/>
               </a:rPr>
-              <a:t>The test is an executable statement about behavior, not a coverage ornament.</a:t>
+              <a:t>Missing tests normally warn; exemptions are not evidence of correctness.</a:t>
             </a:r>
           </a:p>
         </p:txBody>
@@ -5263,7 +5273,7 @@
                 </a:solidFill>
                 <a:latin typeface="Courier New"/>
               </a:rPr>
-              <a:t>    ...</a:t>
+              <a:t>    if (== b 0) { return a }</a:t>
             </a:r>
           </a:p>
           <a:p>
@@ -5274,6 +5284,17 @@
                 </a:solidFill>
                 <a:latin typeface="Courier New"/>
               </a:rPr>
+              <a:t>    return (gcd b (% a b))</a:t>
+            </a:r>
+          </a:p>
+          <a:p>
+            <a:r>
+              <a:rPr sz="1600" b="0">
+                <a:solidFill>
+                  <a:srgbClr val="EEF1F3"/>
+                </a:solidFill>
+                <a:latin typeface="Courier New"/>
+              </a:rPr>
               <a:t>}</a:t>
             </a:r>
           </a:p>
@@ -5298,6 +5319,28 @@
                 <a:latin typeface="Courier New"/>
               </a:rPr>
               <a:t>    assert (== (gcd 48 18) 6)</a:t>
+            </a:r>
+          </a:p>
+          <a:p>
+            <a:r>
+              <a:rPr sz="1600" b="0">
+                <a:solidFill>
+                  <a:srgbClr val="EEF1F3"/>
+                </a:solidFill>
+                <a:latin typeface="Courier New"/>
+              </a:rPr>
+              <a:t>    assert (== (gcd 18 0) 18)</a:t>
+            </a:r>
+          </a:p>
+          <a:p>
+            <a:r>
+              <a:rPr sz="1600" b="0">
+                <a:solidFill>
+                  <a:srgbClr val="EEF1F3"/>
+                </a:solidFill>
+                <a:latin typeface="Courier New"/>
+              </a:rPr>
+              <a:t>    assert (== (gcd 0 0) 0)</a:t>
             </a:r>
           </a:p>
           <a:p>
@@ -5342,7 +5385,7 @@
                 </a:solidFill>
                 <a:latin typeface="Arial"/>
               </a:rPr>
-              <a:t>2,632 NanoISA tests</a:t>
+              <a:t>Useful tests: policy</a:t>
             </a:r>
           </a:p>
           <a:p>
@@ -5353,7 +5396,7 @@
                 </a:solidFill>
                 <a:latin typeface="Arial"/>
               </a:rPr>
-              <a:t>621 NanoVM tests</a:t>
+              <a:t>Missing tests: warnings</a:t>
             </a:r>
           </a:p>
           <a:p>
@@ -5364,7 +5407,7 @@
                 </a:solidFill>
                 <a:latin typeface="Arial"/>
               </a:rPr>
-              <a:t>93 verifier tests</a:t>
+              <a:t>Exemptions: documented</a:t>
             </a:r>
           </a:p>
           <a:p>
@@ -5375,7 +5418,52 @@
                 </a:solidFill>
                 <a:latin typeface="Arial"/>
               </a:rPr>
-              <a:t>63 NanoVirt tests</a:t>
+              <a:t>Imports: tested by default</a:t>
+            </a:r>
+          </a:p>
+        </p:txBody>
+      </p:sp>
+      <p:sp>
+        <p:nvSpPr>
+          <p:cNvPr id="10" name="TextBox 9"/>
+          <p:cNvSpPr txBox="1"/>
+          <p:nvPr/>
+        </p:nvSpPr>
+        <p:spPr>
+          <a:xfrm>
+            <a:off x="6537960" y="4480560"/>
+            <a:ext cx="4297680" cy="640080"/>
+          </a:xfrm>
+          <a:prstGeom prst="rect">
+            <a:avLst/>
+          </a:prstGeom>
+          <a:noFill/>
+        </p:spPr>
+        <p:txBody>
+          <a:bodyPr wrap="square" lIns="45720" rIns="45720" tIns="27432" bIns="27432" anchor="t">
+            <a:spAutoFit/>
+          </a:bodyPr>
+          <a:lstStyle/>
+          <a:p>
+            <a:r>
+              <a:rPr sz="1400" b="0">
+                <a:solidFill>
+                  <a:srgbClr val="EEF1F3"/>
+                </a:solidFill>
+                <a:latin typeface="Arial"/>
+              </a:rPr>
+              <a:t>Separate test process;</a:t>
+            </a:r>
+          </a:p>
+          <a:p>
+            <a:r>
+              <a:rPr sz="1400" b="0">
+                <a:solidFill>
+                  <a:srgbClr val="EEF1F3"/>
+                </a:solidFill>
+                <a:latin typeface="Arial"/>
+              </a:rPr>
+              <a:t>source-only emission skips tests.</a:t>
             </a:r>
           </a:p>
         </p:txBody>
@@ -5941,7 +6029,7 @@
                 </a:solidFill>
                 <a:latin typeface="Arial"/>
               </a:rPr>
-              <a:t>isolation costs about 48x per crossing — which is what batching exists to amortize</a:t>
+              <a:t>Historical 4.0 measurement: about 48x per crossing in the recorded setup.</a:t>
             </a:r>
           </a:p>
         </p:txBody>
@@ -6036,7 +6124,7 @@
                 </a:solidFill>
                 <a:latin typeface="Arial"/>
               </a:rPr>
-              <a:t>I collect cycles, so my backends agree about leaks.</a:t>
+              <a:t>I collect tested reference cycles.</a:t>
             </a:r>
           </a:p>
         </p:txBody>
@@ -6070,7 +6158,7 @@
                 </a:solidFill>
                 <a:latin typeface="Arial"/>
               </a:rPr>
-              <a:t>Reference counting cannot reclaim a cycle, and a cycle is constructible from ordinary NanoLang.</a:t>
+              <a:t>Cycle collection is not complete leak freedom or backend semantic equivalence.</a:t>
             </a:r>
           </a:p>
         </p:txBody>
@@ -7401,7 +7489,7 @@
                 </a:solidFill>
                 <a:latin typeface="Arial"/>
               </a:rPr>
-              <a:t>I host a secure runtime on an ordinary kernel.</a:t>
+              <a:t>I build runtime foundations on an ordinary kernel.</a:t>
             </a:r>
           </a:p>
         </p:txBody>
@@ -7435,7 +7523,7 @@
                 </a:solidFill>
                 <a:latin typeface="Arial"/>
               </a:rPr>
-              <a:t>Contracts, capabilities, a POSIX fabric, and a journal. Five layers. Not synonyms.</a:t>
+              <a:t>Contracts, capabilities, a POSIX fabric, and a journal. Laboratory evidence, not production isolation.</a:t>
             </a:r>
           </a:p>
         </p:txBody>
@@ -8059,7 +8147,7 @@
                 </a:solidFill>
                 <a:latin typeface="Arial"/>
               </a:rPr>
-              <a:t>unforgeable</a:t>
+              <a:t>checked handle</a:t>
             </a:r>
           </a:p>
         </p:txBody>
@@ -8287,7 +8375,7 @@
                 </a:solidFill>
                 <a:latin typeface="Arial"/>
               </a:rPr>
-              <a:t>4.1–4.5 shipped. Here is what I have not done.</a:t>
+              <a:t>4.1–4.5 history, and the work still ahead.</a:t>
             </a:r>
           </a:p>
         </p:txBody>
@@ -8321,7 +8409,7 @@
                 </a:solidFill>
                 <a:latin typeface="Arial"/>
               </a:rPr>
-              <a:t>One public tag from v4.0.0. Five product phases, not five GitHub Releases.</a:t>
+              <a:t>The current 5.0 draft is not a release-readiness claim.</a:t>
             </a:r>
           </a:p>
         </p:txBody>
@@ -8534,7 +8622,7 @@
                 </a:solidFill>
                 <a:latin typeface="Arial"/>
               </a:rPr>
-              <a:t>unforgeable capabilities</a:t>
+              <a:t>capability APIs</a:t>
             </a:r>
           </a:p>
           <a:p>
@@ -9084,7 +9172,7 @@
                 </a:solidFill>
                 <a:latin typeface="Arial"/>
               </a:rPr>
-              <a:t>Machines write code now. The bottleneck is checking it.</a:t>
+              <a:t>I make calls and test obligations explicit.</a:t>
             </a:r>
           </a:p>
         </p:txBody>
@@ -9118,7 +9206,7 @@
                 </a:solidFill>
                 <a:latin typeface="Arial"/>
               </a:rPr>
-              <a:t>So I refuse ambiguity: one canonical form, explicit boundaries, and evidence required to compile.</a:t>
+              <a:t>I recommend canonical forms; my parser also accepts legacy syntax.</a:t>
             </a:r>
           </a:p>
         </p:txBody>
@@ -9486,7 +9574,7 @@
                 </a:solidFill>
                 <a:latin typeface="Arial"/>
               </a:rPr>
-              <a:t>PROOF</a:t>
+              <a:t>TESTS</a:t>
             </a:r>
           </a:p>
         </p:txBody>
@@ -9520,7 +9608,7 @@
                 </a:solidFill>
                 <a:latin typeface="Courier New"/>
               </a:rPr>
-              <a:t>shadow fn { ... }</a:t>
+              <a:t>shadow gcd { ... }</a:t>
             </a:r>
           </a:p>
         </p:txBody>
@@ -11432,7 +11520,7 @@
                 </a:solidFill>
                 <a:latin typeface="Arial"/>
               </a:rPr>
-              <a:t>My verifier proves a program before it runs.</a:t>
+              <a:t>My verifier checks modeled invariants before execution.</a:t>
             </a:r>
           </a:p>
         </p:txBody>
@@ -11466,7 +11554,7 @@
                 </a:solidFill>
                 <a:latin typeface="Arial"/>
               </a:rPr>
-              <a:t>Each property below was a run-time trap. Now it is a rejection.</a:t>
+              <a:t>These checks are not whole-program proof or complete source ownership.</a:t>
             </a:r>
           </a:p>
         </p:txBody>
@@ -11757,7 +11845,7 @@
                 </a:solidFill>
                 <a:latin typeface="Arial"/>
               </a:rPr>
-              <a:t>a known contradiction is refused; unknown never fails</a:t>
+              <a:t>known contradictions are refused; unknown stays unknown</a:t>
             </a:r>
           </a:p>
         </p:txBody>
@@ -12056,7 +12144,7 @@
                 </a:solidFill>
                 <a:latin typeface="Arial"/>
               </a:rPr>
-              <a:t>ownership</a:t>
+              <a:t>reference balance</a:t>
             </a:r>
           </a:p>
         </p:txBody>
@@ -12090,7 +12178,7 @@
                 </a:solidFill>
                 <a:latin typeface="Arial"/>
               </a:rPr>
-              <a:t>retain and release must balance on every path</a:t>
+              <a:t>explicit retain/release counts, not object identity</a:t>
             </a:r>
           </a:p>
         </p:txBody>
@@ -12727,7 +12815,7 @@
                 </a:solidFill>
                 <a:latin typeface="Arial"/>
               </a:rPr>
-              <a:t>The verifier is one defence. The parsers underneath it are the other, and they are fuzzed.</a:t>
+              <a:t>My verifier and parsers have malformed-input tests; their coverage is not universal.</a:t>
             </a:r>
           </a:p>
         </p:txBody>
@@ -13315,7 +13403,7 @@
         <p:spPr>
           <a:xfrm>
             <a:off x="1051560" y="3794760"/>
-            <a:ext cx="4572000" cy="320040"/>
+            <a:ext cx="10058400" cy="320040"/>
           </a:xfrm>
           <a:prstGeom prst="rect">
             <a:avLst/>
@@ -13335,7 +13423,7 @@
                 </a:solidFill>
                 <a:latin typeface="Courier New"/>
               </a:rPr>
-              <a:t>size &gt; total - offset</a:t>
+              <a:t>offset &gt; total || size &gt; total - offset</a:t>
             </a:r>
           </a:p>
         </p:txBody>
@@ -13343,40 +13431,6 @@
       <p:sp>
         <p:nvSpPr>
           <p:cNvPr id="21" name="TextBox 20"/>
-          <p:cNvSpPr txBox="1"/>
-          <p:nvPr/>
-        </p:nvSpPr>
-        <p:spPr>
-          <a:xfrm>
-            <a:off x="6035040" y="3840480"/>
-            <a:ext cx="5120640" cy="274320"/>
-          </a:xfrm>
-          <a:prstGeom prst="rect">
-            <a:avLst/>
-          </a:prstGeom>
-          <a:noFill/>
-        </p:spPr>
-        <p:txBody>
-          <a:bodyPr wrap="square" lIns="45720" rIns="45720" tIns="27432" bIns="27432" anchor="t">
-            <a:spAutoFit/>
-          </a:bodyPr>
-          <a:lstStyle/>
-          <a:p>
-            <a:r>
-              <a:rPr sz="1500" b="1">
-                <a:solidFill>
-                  <a:srgbClr val="65707C"/>
-                </a:solidFill>
-                <a:latin typeface="Courier New"/>
-              </a:rPr>
-              <a:t>never  offset + size &gt; total</a:t>
-            </a:r>
-          </a:p>
-        </p:txBody>
-      </p:sp>
-      <p:sp>
-        <p:nvSpPr>
-          <p:cNvPr id="22" name="TextBox 21"/>
           <p:cNvSpPr txBox="1"/>
           <p:nvPr/>
         </p:nvSpPr>
@@ -13403,14 +13457,14 @@
                 </a:solidFill>
                 <a:latin typeface="Arial"/>
               </a:rPr>
-              <a:t>The second form wraps, so an offset near the top of the range passes the check that exists to stop it. Every range in the v2 decoder is written as the first form. Argument limits agree across imports, traps, direct FFI and the co-process, so no path is the lenient one.</a:t>
-            </a:r>
-          </a:p>
-        </p:txBody>
-      </p:sp>
-      <p:sp>
-        <p:nvSpPr>
-          <p:cNvPr id="23" name="TextBox 22"/>
+              <a:t>I bound the offset before subtracting. An unchecked addition or subtraction can wrap. My deterministic malformed-input suites exercise these parsing boundaries; passing their cases is not proof for arbitrary bytes or an unlimited fuzzing campaign.</a:t>
+            </a:r>
+          </a:p>
+        </p:txBody>
+      </p:sp>
+      <p:sp>
+        <p:nvSpPr>
+          <p:cNvPr id="22" name="TextBox 21"/>
           <p:cNvSpPr txBox="1"/>
           <p:nvPr/>
         </p:nvSpPr>
@@ -13438,7 +13492,7 @@
                 </a:solidFill>
                 <a:latin typeface="Courier New"/>
               </a:rPr>
-              <a:t>784 lines of fuzz and malformed-input tests, added in 4.0, across all six</a:t>
+              <a:t>Malformed-input tests are evidence, not universal safety proofs.</a:t>
             </a:r>
           </a:p>
         </p:txBody>
@@ -13567,7 +13621,7 @@
                 </a:solidFill>
                 <a:latin typeface="Arial"/>
               </a:rPr>
-              <a:t>One copy of 161 handlers, reached two ways. Adopted on measurement, not principle.</a:t>
+              <a:t>Historical 4.0 measurement: one handler body, two dispatch strategies.</a:t>
             </a:r>
           </a:p>
         </p:txBody>

</xml_diff>

<commit_message>
MAC task task_92e6817607cf4071ab614289911a9a41: Retain assembler include-search inputs in module builds
</commit_message>
<xml_diff>
--- a/docs/presentation/nanolang-developer-overview.pptx
+++ b/docs/presentation/nanolang-developer-overview.pptx
@@ -522,7 +522,7 @@
           </a:p>
           <a:p>
             <a:r>
-              <a:t>I am a language and a secure runtime. I do not claim a kernel.</a:t>
+              <a:t>I am a language with a runtime under development. This local draft is not a release or a production-isolation claim.</a:t>
             </a:r>
           </a:p>
           <a:p>
@@ -597,12 +597,22 @@
           <a:lstStyle/>
           <a:p>
             <a:r>
-              <a:t>Authority: CONTRIBUTING.md and the current test suites, counted at the v4.0.0 tag.</a:t>
-            </a:r>
-          </a:p>
-          <a:p>
-            <a:r>
-              <a:t>make test-verify-all-programs additionally verifies every program in tests/, because compiling is not verifying.</a:t>
+              <a:t>Authority: CONTRIBUTING.md, docs/CANONICAL_STYLE.md, tests/test_language_claims.py and examples/gcd.nano.</a:t>
+            </a:r>
+          </a:p>
+          <a:p>
+            <a:r>
+              <a:t>CPU exemptions include externs, main, generated lambdas and functions using extern calls. Explicit foreign-call shadows still run.</a:t>
+            </a:r>
+          </a:p>
+          <a:p>
+            <a:r>
+              <a:t>All three drivers select dependency shadows by default; --root-shadows-only opts out. Test processes have deadlines, not sandboxing.</a:t>
+            </a:r>
+          </a:p>
+          <a:p>
+            <a:r>
+              <a:t>I exercise nonnegative and zero gcd inputs here. These assertions are not a theorem for all integers.</a:t>
             </a:r>
           </a:p>
         </p:txBody>
@@ -1142,17 +1152,12 @@
           </a:p>
           <a:p>
             <a:r>
-              <a:t>This slide carries the thesis. Everything after it is a mechanism serving this claim,</a:t>
-            </a:r>
-          </a:p>
-          <a:p>
-            <a:r>
-              <a:t>and a reader who does not accept it here will not care about the module format.</a:t>
-            </a:r>
-          </a:p>
-          <a:p>
-            <a:r>
-              <a:t>PROOF is not decoration: a function without a shadow test does not compile.</a:t>
+              <a:t>My project policy requires useful shadows. My compiler normally warns about missing tests, with documented exemptions.</a:t>
+            </a:r>
+          </a:p>
+          <a:p>
+            <a:r>
+              <a:t>A shadow tests its assertions; it does not prove every input. Compiler acceptance is not proof of correctness.</a:t>
             </a:r>
           </a:p>
         </p:txBody>
@@ -1452,7 +1457,12 @@
           </a:p>
           <a:p>
             <a:r>
-              <a:t>Every call now carries its signature, so a module is provable before it is linked.</a:t>
+              <a:t>Imported signatures are declarations, not proof of foreign behavior. My abstract reference counter does not identify objects.</a:t>
+            </a:r>
+          </a:p>
+          <a:p>
+            <a:r>
+              <a:t>Formal NanoCore theorems and compiler correspondence are separate boundaries; see formal/README.md and docs/ROADMAP.md.</a:t>
             </a:r>
           </a:p>
         </p:txBody>
@@ -1607,7 +1617,7 @@
           </a:p>
           <a:p>
             <a:r>
-              <a:t>784 lines of fuzz and malformed-input tests were added in 4.0 across the six surfaces named here.</a:t>
+              <a:t>I distinguish deterministic malformed-input testing, seed replay and mutation campaigns.</a:t>
             </a:r>
           </a:p>
           <a:p>
@@ -1692,7 +1702,7 @@
           </a:p>
           <a:p>
             <a:r>
-              <a:t>VM_CASE and VM_NEXT are the only difference, so the two strategies cannot drift in what an instruction does.</a:t>
+              <a:t>Shared handler bodies reduce duplication; execution equivalence still needs tests.</a:t>
             </a:r>
           </a:p>
           <a:p>
@@ -4842,7 +4852,7 @@
                 </a:solidFill>
                 <a:latin typeface="Arial"/>
               </a:rPr>
-              <a:t>NANOLANG 4.5</a:t>
+              <a:t>NANOLANG 5.0 DRAFT</a:t>
             </a:r>
           </a:p>
         </p:txBody>
@@ -4943,7 +4953,7 @@
                 </a:solidFill>
                 <a:latin typeface="Arial"/>
               </a:rPr>
-              <a:t>A developer's view of my syntax, compiler, NanoISA, and the secure runtime I host on POSIX.</a:t>
+              <a:t>A developer's view of my syntax, compiler, NanoISA, and runtime foundations on POSIX.</a:t>
             </a:r>
           </a:p>
         </p:txBody>
@@ -5072,7 +5082,7 @@
                 </a:solidFill>
                 <a:latin typeface="Arial"/>
               </a:rPr>
-              <a:t>Every function carries a shadow test.</a:t>
+              <a:t>I require useful shadows by project policy.</a:t>
             </a:r>
           </a:p>
         </p:txBody>
@@ -5106,7 +5116,7 @@
                 </a:solidFill>
                 <a:latin typeface="Arial"/>
               </a:rPr>
-              <a:t>The test is an executable statement about behavior, not a coverage ornament.</a:t>
+              <a:t>Missing tests normally warn; exemptions are not evidence of correctness.</a:t>
             </a:r>
           </a:p>
         </p:txBody>
@@ -5263,7 +5273,7 @@
                 </a:solidFill>
                 <a:latin typeface="Courier New"/>
               </a:rPr>
-              <a:t>    ...</a:t>
+              <a:t>    if (== b 0) { return a }</a:t>
             </a:r>
           </a:p>
           <a:p>
@@ -5274,6 +5284,17 @@
                 </a:solidFill>
                 <a:latin typeface="Courier New"/>
               </a:rPr>
+              <a:t>    return (gcd b (% a b))</a:t>
+            </a:r>
+          </a:p>
+          <a:p>
+            <a:r>
+              <a:rPr sz="1600" b="0">
+                <a:solidFill>
+                  <a:srgbClr val="EEF1F3"/>
+                </a:solidFill>
+                <a:latin typeface="Courier New"/>
+              </a:rPr>
               <a:t>}</a:t>
             </a:r>
           </a:p>
@@ -5298,6 +5319,28 @@
                 <a:latin typeface="Courier New"/>
               </a:rPr>
               <a:t>    assert (== (gcd 48 18) 6)</a:t>
+            </a:r>
+          </a:p>
+          <a:p>
+            <a:r>
+              <a:rPr sz="1600" b="0">
+                <a:solidFill>
+                  <a:srgbClr val="EEF1F3"/>
+                </a:solidFill>
+                <a:latin typeface="Courier New"/>
+              </a:rPr>
+              <a:t>    assert (== (gcd 18 0) 18)</a:t>
+            </a:r>
+          </a:p>
+          <a:p>
+            <a:r>
+              <a:rPr sz="1600" b="0">
+                <a:solidFill>
+                  <a:srgbClr val="EEF1F3"/>
+                </a:solidFill>
+                <a:latin typeface="Courier New"/>
+              </a:rPr>
+              <a:t>    assert (== (gcd 0 0) 0)</a:t>
             </a:r>
           </a:p>
           <a:p>
@@ -5342,7 +5385,7 @@
                 </a:solidFill>
                 <a:latin typeface="Arial"/>
               </a:rPr>
-              <a:t>2,632 NanoISA tests</a:t>
+              <a:t>Useful tests: policy</a:t>
             </a:r>
           </a:p>
           <a:p>
@@ -5353,7 +5396,7 @@
                 </a:solidFill>
                 <a:latin typeface="Arial"/>
               </a:rPr>
-              <a:t>621 NanoVM tests</a:t>
+              <a:t>Missing tests: warnings</a:t>
             </a:r>
           </a:p>
           <a:p>
@@ -5364,7 +5407,7 @@
                 </a:solidFill>
                 <a:latin typeface="Arial"/>
               </a:rPr>
-              <a:t>93 verifier tests</a:t>
+              <a:t>Exemptions: documented</a:t>
             </a:r>
           </a:p>
           <a:p>
@@ -5375,7 +5418,52 @@
                 </a:solidFill>
                 <a:latin typeface="Arial"/>
               </a:rPr>
-              <a:t>63 NanoVirt tests</a:t>
+              <a:t>Imports: tested by default</a:t>
+            </a:r>
+          </a:p>
+        </p:txBody>
+      </p:sp>
+      <p:sp>
+        <p:nvSpPr>
+          <p:cNvPr id="10" name="TextBox 9"/>
+          <p:cNvSpPr txBox="1"/>
+          <p:nvPr/>
+        </p:nvSpPr>
+        <p:spPr>
+          <a:xfrm>
+            <a:off x="6537960" y="4480560"/>
+            <a:ext cx="4297680" cy="640080"/>
+          </a:xfrm>
+          <a:prstGeom prst="rect">
+            <a:avLst/>
+          </a:prstGeom>
+          <a:noFill/>
+        </p:spPr>
+        <p:txBody>
+          <a:bodyPr wrap="square" lIns="45720" rIns="45720" tIns="27432" bIns="27432" anchor="t">
+            <a:spAutoFit/>
+          </a:bodyPr>
+          <a:lstStyle/>
+          <a:p>
+            <a:r>
+              <a:rPr sz="1400" b="0">
+                <a:solidFill>
+                  <a:srgbClr val="EEF1F3"/>
+                </a:solidFill>
+                <a:latin typeface="Arial"/>
+              </a:rPr>
+              <a:t>Separate test process;</a:t>
+            </a:r>
+          </a:p>
+          <a:p>
+            <a:r>
+              <a:rPr sz="1400" b="0">
+                <a:solidFill>
+                  <a:srgbClr val="EEF1F3"/>
+                </a:solidFill>
+                <a:latin typeface="Arial"/>
+              </a:rPr>
+              <a:t>source-only emission skips tests.</a:t>
             </a:r>
           </a:p>
         </p:txBody>
@@ -5941,7 +6029,7 @@
                 </a:solidFill>
                 <a:latin typeface="Arial"/>
               </a:rPr>
-              <a:t>isolation costs about 48x per crossing — which is what batching exists to amortize</a:t>
+              <a:t>Historical 4.0 measurement: about 48x per crossing in the recorded setup.</a:t>
             </a:r>
           </a:p>
         </p:txBody>
@@ -6036,7 +6124,7 @@
                 </a:solidFill>
                 <a:latin typeface="Arial"/>
               </a:rPr>
-              <a:t>I collect cycles, so my backends agree about leaks.</a:t>
+              <a:t>I collect tested reference cycles.</a:t>
             </a:r>
           </a:p>
         </p:txBody>
@@ -6070,7 +6158,7 @@
                 </a:solidFill>
                 <a:latin typeface="Arial"/>
               </a:rPr>
-              <a:t>Reference counting cannot reclaim a cycle, and a cycle is constructible from ordinary NanoLang.</a:t>
+              <a:t>Cycle collection is not complete leak freedom or backend semantic equivalence.</a:t>
             </a:r>
           </a:p>
         </p:txBody>
@@ -7401,7 +7489,7 @@
                 </a:solidFill>
                 <a:latin typeface="Arial"/>
               </a:rPr>
-              <a:t>I host a secure runtime on an ordinary kernel.</a:t>
+              <a:t>I build runtime foundations on an ordinary kernel.</a:t>
             </a:r>
           </a:p>
         </p:txBody>
@@ -7435,7 +7523,7 @@
                 </a:solidFill>
                 <a:latin typeface="Arial"/>
               </a:rPr>
-              <a:t>Contracts, capabilities, a POSIX fabric, and a journal. Five layers. Not synonyms.</a:t>
+              <a:t>Contracts, capabilities, a POSIX fabric, and a journal. Laboratory evidence, not production isolation.</a:t>
             </a:r>
           </a:p>
         </p:txBody>
@@ -8059,7 +8147,7 @@
                 </a:solidFill>
                 <a:latin typeface="Arial"/>
               </a:rPr>
-              <a:t>unforgeable</a:t>
+              <a:t>checked handle</a:t>
             </a:r>
           </a:p>
         </p:txBody>
@@ -8287,7 +8375,7 @@
                 </a:solidFill>
                 <a:latin typeface="Arial"/>
               </a:rPr>
-              <a:t>4.1–4.5 shipped. Here is what I have not done.</a:t>
+              <a:t>4.1–4.5 history, and the work still ahead.</a:t>
             </a:r>
           </a:p>
         </p:txBody>
@@ -8321,7 +8409,7 @@
                 </a:solidFill>
                 <a:latin typeface="Arial"/>
               </a:rPr>
-              <a:t>One public tag from v4.0.0. Five product phases, not five GitHub Releases.</a:t>
+              <a:t>The current 5.0 draft is not a release-readiness claim.</a:t>
             </a:r>
           </a:p>
         </p:txBody>
@@ -8534,7 +8622,7 @@
                 </a:solidFill>
                 <a:latin typeface="Arial"/>
               </a:rPr>
-              <a:t>unforgeable capabilities</a:t>
+              <a:t>capability APIs</a:t>
             </a:r>
           </a:p>
           <a:p>
@@ -9084,7 +9172,7 @@
                 </a:solidFill>
                 <a:latin typeface="Arial"/>
               </a:rPr>
-              <a:t>Machines write code now. The bottleneck is checking it.</a:t>
+              <a:t>I make calls and test obligations explicit.</a:t>
             </a:r>
           </a:p>
         </p:txBody>
@@ -9118,7 +9206,7 @@
                 </a:solidFill>
                 <a:latin typeface="Arial"/>
               </a:rPr>
-              <a:t>So I refuse ambiguity: one canonical form, explicit boundaries, and evidence required to compile.</a:t>
+              <a:t>I recommend canonical forms; my parser also accepts legacy syntax.</a:t>
             </a:r>
           </a:p>
         </p:txBody>
@@ -9486,7 +9574,7 @@
                 </a:solidFill>
                 <a:latin typeface="Arial"/>
               </a:rPr>
-              <a:t>PROOF</a:t>
+              <a:t>TESTS</a:t>
             </a:r>
           </a:p>
         </p:txBody>
@@ -9520,7 +9608,7 @@
                 </a:solidFill>
                 <a:latin typeface="Courier New"/>
               </a:rPr>
-              <a:t>shadow fn { ... }</a:t>
+              <a:t>shadow gcd { ... }</a:t>
             </a:r>
           </a:p>
         </p:txBody>
@@ -11432,7 +11520,7 @@
                 </a:solidFill>
                 <a:latin typeface="Arial"/>
               </a:rPr>
-              <a:t>My verifier proves a program before it runs.</a:t>
+              <a:t>My verifier checks modeled invariants before execution.</a:t>
             </a:r>
           </a:p>
         </p:txBody>
@@ -11466,7 +11554,7 @@
                 </a:solidFill>
                 <a:latin typeface="Arial"/>
               </a:rPr>
-              <a:t>Each property below was a run-time trap. Now it is a rejection.</a:t>
+              <a:t>These checks are not whole-program proof or complete source ownership.</a:t>
             </a:r>
           </a:p>
         </p:txBody>
@@ -11757,7 +11845,7 @@
                 </a:solidFill>
                 <a:latin typeface="Arial"/>
               </a:rPr>
-              <a:t>a known contradiction is refused; unknown never fails</a:t>
+              <a:t>known contradictions are refused; unknown stays unknown</a:t>
             </a:r>
           </a:p>
         </p:txBody>
@@ -12056,7 +12144,7 @@
                 </a:solidFill>
                 <a:latin typeface="Arial"/>
               </a:rPr>
-              <a:t>ownership</a:t>
+              <a:t>reference balance</a:t>
             </a:r>
           </a:p>
         </p:txBody>
@@ -12090,7 +12178,7 @@
                 </a:solidFill>
                 <a:latin typeface="Arial"/>
               </a:rPr>
-              <a:t>retain and release must balance on every path</a:t>
+              <a:t>explicit retain/release counts, not object identity</a:t>
             </a:r>
           </a:p>
         </p:txBody>
@@ -12727,7 +12815,7 @@
                 </a:solidFill>
                 <a:latin typeface="Arial"/>
               </a:rPr>
-              <a:t>The verifier is one defence. The parsers underneath it are the other, and they are fuzzed.</a:t>
+              <a:t>My verifier and parsers have malformed-input tests; their coverage is not universal.</a:t>
             </a:r>
           </a:p>
         </p:txBody>
@@ -13315,7 +13403,7 @@
         <p:spPr>
           <a:xfrm>
             <a:off x="1051560" y="3794760"/>
-            <a:ext cx="4572000" cy="320040"/>
+            <a:ext cx="10058400" cy="320040"/>
           </a:xfrm>
           <a:prstGeom prst="rect">
             <a:avLst/>
@@ -13335,7 +13423,7 @@
                 </a:solidFill>
                 <a:latin typeface="Courier New"/>
               </a:rPr>
-              <a:t>size &gt; total - offset</a:t>
+              <a:t>offset &gt; total || size &gt; total - offset</a:t>
             </a:r>
           </a:p>
         </p:txBody>
@@ -13343,40 +13431,6 @@
       <p:sp>
         <p:nvSpPr>
           <p:cNvPr id="21" name="TextBox 20"/>
-          <p:cNvSpPr txBox="1"/>
-          <p:nvPr/>
-        </p:nvSpPr>
-        <p:spPr>
-          <a:xfrm>
-            <a:off x="6035040" y="3840480"/>
-            <a:ext cx="5120640" cy="274320"/>
-          </a:xfrm>
-          <a:prstGeom prst="rect">
-            <a:avLst/>
-          </a:prstGeom>
-          <a:noFill/>
-        </p:spPr>
-        <p:txBody>
-          <a:bodyPr wrap="square" lIns="45720" rIns="45720" tIns="27432" bIns="27432" anchor="t">
-            <a:spAutoFit/>
-          </a:bodyPr>
-          <a:lstStyle/>
-          <a:p>
-            <a:r>
-              <a:rPr sz="1500" b="1">
-                <a:solidFill>
-                  <a:srgbClr val="65707C"/>
-                </a:solidFill>
-                <a:latin typeface="Courier New"/>
-              </a:rPr>
-              <a:t>never  offset + size &gt; total</a:t>
-            </a:r>
-          </a:p>
-        </p:txBody>
-      </p:sp>
-      <p:sp>
-        <p:nvSpPr>
-          <p:cNvPr id="22" name="TextBox 21"/>
           <p:cNvSpPr txBox="1"/>
           <p:nvPr/>
         </p:nvSpPr>
@@ -13403,14 +13457,14 @@
                 </a:solidFill>
                 <a:latin typeface="Arial"/>
               </a:rPr>
-              <a:t>The second form wraps, so an offset near the top of the range passes the check that exists to stop it. Every range in the v2 decoder is written as the first form. Argument limits agree across imports, traps, direct FFI and the co-process, so no path is the lenient one.</a:t>
-            </a:r>
-          </a:p>
-        </p:txBody>
-      </p:sp>
-      <p:sp>
-        <p:nvSpPr>
-          <p:cNvPr id="23" name="TextBox 22"/>
+              <a:t>I bound the offset before subtracting. An unchecked addition or subtraction can wrap. My deterministic malformed-input suites exercise these parsing boundaries; passing their cases is not proof for arbitrary bytes or an unlimited fuzzing campaign.</a:t>
+            </a:r>
+          </a:p>
+        </p:txBody>
+      </p:sp>
+      <p:sp>
+        <p:nvSpPr>
+          <p:cNvPr id="22" name="TextBox 21"/>
           <p:cNvSpPr txBox="1"/>
           <p:nvPr/>
         </p:nvSpPr>
@@ -13438,7 +13492,7 @@
                 </a:solidFill>
                 <a:latin typeface="Courier New"/>
               </a:rPr>
-              <a:t>784 lines of fuzz and malformed-input tests, added in 4.0, across all six</a:t>
+              <a:t>Malformed-input tests are evidence, not universal safety proofs.</a:t>
             </a:r>
           </a:p>
         </p:txBody>
@@ -13567,7 +13621,7 @@
                 </a:solidFill>
                 <a:latin typeface="Arial"/>
               </a:rPr>
-              <a:t>One copy of 161 handlers, reached two ways. Adopted on measurement, not principle.</a:t>
+              <a:t>Historical 4.0 measurement: one handler body, two dispatch strategies.</a:t>
             </a:r>
           </a:p>
         </p:txBody>

</xml_diff>

<commit_message>
MAC task task_8500a5ea65584cc3a5cfb02a7812b16b: Preserve paired compiler arguments across metadata fragments
</commit_message>
<xml_diff>
--- a/docs/presentation/nanolang-developer-overview.pptx
+++ b/docs/presentation/nanolang-developer-overview.pptx
@@ -522,7 +522,7 @@
           </a:p>
           <a:p>
             <a:r>
-              <a:t>I am a language and a secure runtime. I do not claim a kernel.</a:t>
+              <a:t>I am a language with a runtime under development. This local draft is not a release or a production-isolation claim.</a:t>
             </a:r>
           </a:p>
           <a:p>
@@ -597,12 +597,22 @@
           <a:lstStyle/>
           <a:p>
             <a:r>
-              <a:t>Authority: CONTRIBUTING.md and the current test suites, counted at the v4.0.0 tag.</a:t>
-            </a:r>
-          </a:p>
-          <a:p>
-            <a:r>
-              <a:t>make test-verify-all-programs additionally verifies every program in tests/, because compiling is not verifying.</a:t>
+              <a:t>Authority: CONTRIBUTING.md, docs/CANONICAL_STYLE.md, tests/test_language_claims.py and examples/gcd.nano.</a:t>
+            </a:r>
+          </a:p>
+          <a:p>
+            <a:r>
+              <a:t>CPU exemptions include externs, main, generated lambdas and functions using extern calls. Explicit foreign-call shadows still run.</a:t>
+            </a:r>
+          </a:p>
+          <a:p>
+            <a:r>
+              <a:t>All three drivers select dependency shadows by default; --root-shadows-only opts out. Test processes have deadlines, not sandboxing.</a:t>
+            </a:r>
+          </a:p>
+          <a:p>
+            <a:r>
+              <a:t>I exercise nonnegative and zero gcd inputs here. These assertions are not a theorem for all integers.</a:t>
             </a:r>
           </a:p>
         </p:txBody>
@@ -1142,17 +1152,12 @@
           </a:p>
           <a:p>
             <a:r>
-              <a:t>This slide carries the thesis. Everything after it is a mechanism serving this claim,</a:t>
-            </a:r>
-          </a:p>
-          <a:p>
-            <a:r>
-              <a:t>and a reader who does not accept it here will not care about the module format.</a:t>
-            </a:r>
-          </a:p>
-          <a:p>
-            <a:r>
-              <a:t>PROOF is not decoration: a function without a shadow test does not compile.</a:t>
+              <a:t>My project policy requires useful shadows. My compiler normally warns about missing tests, with documented exemptions.</a:t>
+            </a:r>
+          </a:p>
+          <a:p>
+            <a:r>
+              <a:t>A shadow tests its assertions; it does not prove every input. Compiler acceptance is not proof of correctness.</a:t>
             </a:r>
           </a:p>
         </p:txBody>
@@ -1452,7 +1457,12 @@
           </a:p>
           <a:p>
             <a:r>
-              <a:t>Every call now carries its signature, so a module is provable before it is linked.</a:t>
+              <a:t>Imported signatures are declarations, not proof of foreign behavior. My abstract reference counter does not identify objects.</a:t>
+            </a:r>
+          </a:p>
+          <a:p>
+            <a:r>
+              <a:t>Formal NanoCore theorems and compiler correspondence are separate boundaries; see formal/README.md and docs/ROADMAP.md.</a:t>
             </a:r>
           </a:p>
         </p:txBody>
@@ -1607,7 +1617,7 @@
           </a:p>
           <a:p>
             <a:r>
-              <a:t>784 lines of fuzz and malformed-input tests were added in 4.0 across the six surfaces named here.</a:t>
+              <a:t>I distinguish deterministic malformed-input testing, seed replay and mutation campaigns.</a:t>
             </a:r>
           </a:p>
           <a:p>
@@ -1692,7 +1702,7 @@
           </a:p>
           <a:p>
             <a:r>
-              <a:t>VM_CASE and VM_NEXT are the only difference, so the two strategies cannot drift in what an instruction does.</a:t>
+              <a:t>Shared handler bodies reduce duplication; execution equivalence still needs tests.</a:t>
             </a:r>
           </a:p>
           <a:p>
@@ -4842,7 +4852,7 @@
                 </a:solidFill>
                 <a:latin typeface="Arial"/>
               </a:rPr>
-              <a:t>NANOLANG 4.5</a:t>
+              <a:t>NANOLANG 5.0 DRAFT</a:t>
             </a:r>
           </a:p>
         </p:txBody>
@@ -4943,7 +4953,7 @@
                 </a:solidFill>
                 <a:latin typeface="Arial"/>
               </a:rPr>
-              <a:t>A developer's view of my syntax, compiler, NanoISA, and the secure runtime I host on POSIX.</a:t>
+              <a:t>A developer's view of my syntax, compiler, NanoISA, and runtime foundations on POSIX.</a:t>
             </a:r>
           </a:p>
         </p:txBody>
@@ -5072,7 +5082,7 @@
                 </a:solidFill>
                 <a:latin typeface="Arial"/>
               </a:rPr>
-              <a:t>Every function carries a shadow test.</a:t>
+              <a:t>I require useful shadows by project policy.</a:t>
             </a:r>
           </a:p>
         </p:txBody>
@@ -5106,7 +5116,7 @@
                 </a:solidFill>
                 <a:latin typeface="Arial"/>
               </a:rPr>
-              <a:t>The test is an executable statement about behavior, not a coverage ornament.</a:t>
+              <a:t>Missing tests normally warn; exemptions are not evidence of correctness.</a:t>
             </a:r>
           </a:p>
         </p:txBody>
@@ -5263,7 +5273,7 @@
                 </a:solidFill>
                 <a:latin typeface="Courier New"/>
               </a:rPr>
-              <a:t>    ...</a:t>
+              <a:t>    if (== b 0) { return a }</a:t>
             </a:r>
           </a:p>
           <a:p>
@@ -5274,6 +5284,17 @@
                 </a:solidFill>
                 <a:latin typeface="Courier New"/>
               </a:rPr>
+              <a:t>    return (gcd b (% a b))</a:t>
+            </a:r>
+          </a:p>
+          <a:p>
+            <a:r>
+              <a:rPr sz="1600" b="0">
+                <a:solidFill>
+                  <a:srgbClr val="EEF1F3"/>
+                </a:solidFill>
+                <a:latin typeface="Courier New"/>
+              </a:rPr>
               <a:t>}</a:t>
             </a:r>
           </a:p>
@@ -5298,6 +5319,28 @@
                 <a:latin typeface="Courier New"/>
               </a:rPr>
               <a:t>    assert (== (gcd 48 18) 6)</a:t>
+            </a:r>
+          </a:p>
+          <a:p>
+            <a:r>
+              <a:rPr sz="1600" b="0">
+                <a:solidFill>
+                  <a:srgbClr val="EEF1F3"/>
+                </a:solidFill>
+                <a:latin typeface="Courier New"/>
+              </a:rPr>
+              <a:t>    assert (== (gcd 18 0) 18)</a:t>
+            </a:r>
+          </a:p>
+          <a:p>
+            <a:r>
+              <a:rPr sz="1600" b="0">
+                <a:solidFill>
+                  <a:srgbClr val="EEF1F3"/>
+                </a:solidFill>
+                <a:latin typeface="Courier New"/>
+              </a:rPr>
+              <a:t>    assert (== (gcd 0 0) 0)</a:t>
             </a:r>
           </a:p>
           <a:p>
@@ -5342,7 +5385,7 @@
                 </a:solidFill>
                 <a:latin typeface="Arial"/>
               </a:rPr>
-              <a:t>2,632 NanoISA tests</a:t>
+              <a:t>Useful tests: policy</a:t>
             </a:r>
           </a:p>
           <a:p>
@@ -5353,7 +5396,7 @@
                 </a:solidFill>
                 <a:latin typeface="Arial"/>
               </a:rPr>
-              <a:t>621 NanoVM tests</a:t>
+              <a:t>Missing tests: warnings</a:t>
             </a:r>
           </a:p>
           <a:p>
@@ -5364,7 +5407,7 @@
                 </a:solidFill>
                 <a:latin typeface="Arial"/>
               </a:rPr>
-              <a:t>93 verifier tests</a:t>
+              <a:t>Exemptions: documented</a:t>
             </a:r>
           </a:p>
           <a:p>
@@ -5375,7 +5418,52 @@
                 </a:solidFill>
                 <a:latin typeface="Arial"/>
               </a:rPr>
-              <a:t>63 NanoVirt tests</a:t>
+              <a:t>Imports: tested by default</a:t>
+            </a:r>
+          </a:p>
+        </p:txBody>
+      </p:sp>
+      <p:sp>
+        <p:nvSpPr>
+          <p:cNvPr id="10" name="TextBox 9"/>
+          <p:cNvSpPr txBox="1"/>
+          <p:nvPr/>
+        </p:nvSpPr>
+        <p:spPr>
+          <a:xfrm>
+            <a:off x="6537960" y="4480560"/>
+            <a:ext cx="4297680" cy="640080"/>
+          </a:xfrm>
+          <a:prstGeom prst="rect">
+            <a:avLst/>
+          </a:prstGeom>
+          <a:noFill/>
+        </p:spPr>
+        <p:txBody>
+          <a:bodyPr wrap="square" lIns="45720" rIns="45720" tIns="27432" bIns="27432" anchor="t">
+            <a:spAutoFit/>
+          </a:bodyPr>
+          <a:lstStyle/>
+          <a:p>
+            <a:r>
+              <a:rPr sz="1400" b="0">
+                <a:solidFill>
+                  <a:srgbClr val="EEF1F3"/>
+                </a:solidFill>
+                <a:latin typeface="Arial"/>
+              </a:rPr>
+              <a:t>Separate test process;</a:t>
+            </a:r>
+          </a:p>
+          <a:p>
+            <a:r>
+              <a:rPr sz="1400" b="0">
+                <a:solidFill>
+                  <a:srgbClr val="EEF1F3"/>
+                </a:solidFill>
+                <a:latin typeface="Arial"/>
+              </a:rPr>
+              <a:t>source-only emission skips tests.</a:t>
             </a:r>
           </a:p>
         </p:txBody>
@@ -5941,7 +6029,7 @@
                 </a:solidFill>
                 <a:latin typeface="Arial"/>
               </a:rPr>
-              <a:t>isolation costs about 48x per crossing — which is what batching exists to amortize</a:t>
+              <a:t>Historical 4.0 measurement: about 48x per crossing in the recorded setup.</a:t>
             </a:r>
           </a:p>
         </p:txBody>
@@ -6036,7 +6124,7 @@
                 </a:solidFill>
                 <a:latin typeface="Arial"/>
               </a:rPr>
-              <a:t>I collect cycles, so my backends agree about leaks.</a:t>
+              <a:t>I collect tested reference cycles.</a:t>
             </a:r>
           </a:p>
         </p:txBody>
@@ -6070,7 +6158,7 @@
                 </a:solidFill>
                 <a:latin typeface="Arial"/>
               </a:rPr>
-              <a:t>Reference counting cannot reclaim a cycle, and a cycle is constructible from ordinary NanoLang.</a:t>
+              <a:t>Cycle collection is not complete leak freedom or backend semantic equivalence.</a:t>
             </a:r>
           </a:p>
         </p:txBody>
@@ -7401,7 +7489,7 @@
                 </a:solidFill>
                 <a:latin typeface="Arial"/>
               </a:rPr>
-              <a:t>I host a secure runtime on an ordinary kernel.</a:t>
+              <a:t>I build runtime foundations on an ordinary kernel.</a:t>
             </a:r>
           </a:p>
         </p:txBody>
@@ -7435,7 +7523,7 @@
                 </a:solidFill>
                 <a:latin typeface="Arial"/>
               </a:rPr>
-              <a:t>Contracts, capabilities, a POSIX fabric, and a journal. Five layers. Not synonyms.</a:t>
+              <a:t>Contracts, capabilities, a POSIX fabric, and a journal. Laboratory evidence, not production isolation.</a:t>
             </a:r>
           </a:p>
         </p:txBody>
@@ -8059,7 +8147,7 @@
                 </a:solidFill>
                 <a:latin typeface="Arial"/>
               </a:rPr>
-              <a:t>unforgeable</a:t>
+              <a:t>checked handle</a:t>
             </a:r>
           </a:p>
         </p:txBody>
@@ -8287,7 +8375,7 @@
                 </a:solidFill>
                 <a:latin typeface="Arial"/>
               </a:rPr>
-              <a:t>4.1–4.5 shipped. Here is what I have not done.</a:t>
+              <a:t>4.1–4.5 history, and the work still ahead.</a:t>
             </a:r>
           </a:p>
         </p:txBody>
@@ -8321,7 +8409,7 @@
                 </a:solidFill>
                 <a:latin typeface="Arial"/>
               </a:rPr>
-              <a:t>One public tag from v4.0.0. Five product phases, not five GitHub Releases.</a:t>
+              <a:t>The current 5.0 draft is not a release-readiness claim.</a:t>
             </a:r>
           </a:p>
         </p:txBody>
@@ -8534,7 +8622,7 @@
                 </a:solidFill>
                 <a:latin typeface="Arial"/>
               </a:rPr>
-              <a:t>unforgeable capabilities</a:t>
+              <a:t>capability APIs</a:t>
             </a:r>
           </a:p>
           <a:p>
@@ -9084,7 +9172,7 @@
                 </a:solidFill>
                 <a:latin typeface="Arial"/>
               </a:rPr>
-              <a:t>Machines write code now. The bottleneck is checking it.</a:t>
+              <a:t>I make calls and test obligations explicit.</a:t>
             </a:r>
           </a:p>
         </p:txBody>
@@ -9118,7 +9206,7 @@
                 </a:solidFill>
                 <a:latin typeface="Arial"/>
               </a:rPr>
-              <a:t>So I refuse ambiguity: one canonical form, explicit boundaries, and evidence required to compile.</a:t>
+              <a:t>I recommend canonical forms; my parser also accepts legacy syntax.</a:t>
             </a:r>
           </a:p>
         </p:txBody>
@@ -9486,7 +9574,7 @@
                 </a:solidFill>
                 <a:latin typeface="Arial"/>
               </a:rPr>
-              <a:t>PROOF</a:t>
+              <a:t>TESTS</a:t>
             </a:r>
           </a:p>
         </p:txBody>
@@ -9520,7 +9608,7 @@
                 </a:solidFill>
                 <a:latin typeface="Courier New"/>
               </a:rPr>
-              <a:t>shadow fn { ... }</a:t>
+              <a:t>shadow gcd { ... }</a:t>
             </a:r>
           </a:p>
         </p:txBody>
@@ -11432,7 +11520,7 @@
                 </a:solidFill>
                 <a:latin typeface="Arial"/>
               </a:rPr>
-              <a:t>My verifier proves a program before it runs.</a:t>
+              <a:t>My verifier checks modeled invariants before execution.</a:t>
             </a:r>
           </a:p>
         </p:txBody>
@@ -11466,7 +11554,7 @@
                 </a:solidFill>
                 <a:latin typeface="Arial"/>
               </a:rPr>
-              <a:t>Each property below was a run-time trap. Now it is a rejection.</a:t>
+              <a:t>These checks are not whole-program proof or complete source ownership.</a:t>
             </a:r>
           </a:p>
         </p:txBody>
@@ -11757,7 +11845,7 @@
                 </a:solidFill>
                 <a:latin typeface="Arial"/>
               </a:rPr>
-              <a:t>a known contradiction is refused; unknown never fails</a:t>
+              <a:t>known contradictions are refused; unknown stays unknown</a:t>
             </a:r>
           </a:p>
         </p:txBody>
@@ -12056,7 +12144,7 @@
                 </a:solidFill>
                 <a:latin typeface="Arial"/>
               </a:rPr>
-              <a:t>ownership</a:t>
+              <a:t>reference balance</a:t>
             </a:r>
           </a:p>
         </p:txBody>
@@ -12090,7 +12178,7 @@
                 </a:solidFill>
                 <a:latin typeface="Arial"/>
               </a:rPr>
-              <a:t>retain and release must balance on every path</a:t>
+              <a:t>explicit retain/release counts, not object identity</a:t>
             </a:r>
           </a:p>
         </p:txBody>
@@ -12727,7 +12815,7 @@
                 </a:solidFill>
                 <a:latin typeface="Arial"/>
               </a:rPr>
-              <a:t>The verifier is one defence. The parsers underneath it are the other, and they are fuzzed.</a:t>
+              <a:t>My verifier and parsers have malformed-input tests; their coverage is not universal.</a:t>
             </a:r>
           </a:p>
         </p:txBody>
@@ -13315,7 +13403,7 @@
         <p:spPr>
           <a:xfrm>
             <a:off x="1051560" y="3794760"/>
-            <a:ext cx="4572000" cy="320040"/>
+            <a:ext cx="10058400" cy="320040"/>
           </a:xfrm>
           <a:prstGeom prst="rect">
             <a:avLst/>
@@ -13335,7 +13423,7 @@
                 </a:solidFill>
                 <a:latin typeface="Courier New"/>
               </a:rPr>
-              <a:t>size &gt; total - offset</a:t>
+              <a:t>offset &gt; total || size &gt; total - offset</a:t>
             </a:r>
           </a:p>
         </p:txBody>
@@ -13343,40 +13431,6 @@
       <p:sp>
         <p:nvSpPr>
           <p:cNvPr id="21" name="TextBox 20"/>
-          <p:cNvSpPr txBox="1"/>
-          <p:nvPr/>
-        </p:nvSpPr>
-        <p:spPr>
-          <a:xfrm>
-            <a:off x="6035040" y="3840480"/>
-            <a:ext cx="5120640" cy="274320"/>
-          </a:xfrm>
-          <a:prstGeom prst="rect">
-            <a:avLst/>
-          </a:prstGeom>
-          <a:noFill/>
-        </p:spPr>
-        <p:txBody>
-          <a:bodyPr wrap="square" lIns="45720" rIns="45720" tIns="27432" bIns="27432" anchor="t">
-            <a:spAutoFit/>
-          </a:bodyPr>
-          <a:lstStyle/>
-          <a:p>
-            <a:r>
-              <a:rPr sz="1500" b="1">
-                <a:solidFill>
-                  <a:srgbClr val="65707C"/>
-                </a:solidFill>
-                <a:latin typeface="Courier New"/>
-              </a:rPr>
-              <a:t>never  offset + size &gt; total</a:t>
-            </a:r>
-          </a:p>
-        </p:txBody>
-      </p:sp>
-      <p:sp>
-        <p:nvSpPr>
-          <p:cNvPr id="22" name="TextBox 21"/>
           <p:cNvSpPr txBox="1"/>
           <p:nvPr/>
         </p:nvSpPr>
@@ -13403,14 +13457,14 @@
                 </a:solidFill>
                 <a:latin typeface="Arial"/>
               </a:rPr>
-              <a:t>The second form wraps, so an offset near the top of the range passes the check that exists to stop it. Every range in the v2 decoder is written as the first form. Argument limits agree across imports, traps, direct FFI and the co-process, so no path is the lenient one.</a:t>
-            </a:r>
-          </a:p>
-        </p:txBody>
-      </p:sp>
-      <p:sp>
-        <p:nvSpPr>
-          <p:cNvPr id="23" name="TextBox 22"/>
+              <a:t>I bound the offset before subtracting. An unchecked addition or subtraction can wrap. My deterministic malformed-input suites exercise these parsing boundaries; passing their cases is not proof for arbitrary bytes or an unlimited fuzzing campaign.</a:t>
+            </a:r>
+          </a:p>
+        </p:txBody>
+      </p:sp>
+      <p:sp>
+        <p:nvSpPr>
+          <p:cNvPr id="22" name="TextBox 21"/>
           <p:cNvSpPr txBox="1"/>
           <p:nvPr/>
         </p:nvSpPr>
@@ -13438,7 +13492,7 @@
                 </a:solidFill>
                 <a:latin typeface="Courier New"/>
               </a:rPr>
-              <a:t>784 lines of fuzz and malformed-input tests, added in 4.0, across all six</a:t>
+              <a:t>Malformed-input tests are evidence, not universal safety proofs.</a:t>
             </a:r>
           </a:p>
         </p:txBody>
@@ -13567,7 +13621,7 @@
                 </a:solidFill>
                 <a:latin typeface="Arial"/>
               </a:rPr>
-              <a:t>One copy of 161 handlers, reached two ways. Adopted on measurement, not principle.</a:t>
+              <a:t>Historical 4.0 measurement: one handler body, two dispatch strategies.</a:t>
             </a:r>
           </a:p>
         </p:txBody>

</xml_diff>

<commit_message>
Refresh 5.0 release scope, callback documentation and local presentation
</commit_message>
<xml_diff>
--- a/docs/presentation/nanolang-developer-overview.pptx
+++ b/docs/presentation/nanolang-developer-overview.pptx
@@ -997,17 +997,17 @@
           <a:lstStyle/>
           <a:p>
             <a:r>
-              <a:t>Authority: docs/RELEASE_4.5.md, docs/ROADMAP.md, docs/FORTH_STANDARD_SYSTEM.md, docs/NSI_EFFECTS.md.</a:t>
-            </a:r>
-          </a:p>
-          <a:p>
-            <a:r>
-              <a:t>Catalogs and machine-draft guides exist. JSON/TOON stay English.</a:t>
-            </a:r>
-          </a:p>
-          <a:p>
-            <a:r>
-              <a:t>The live editor uses bin/nano_emacs_worker, not dlopen.</a:t>
+              <a:t>Authority: docs/RELEASE_5.0.md, docs/CALLBACK_ABI.md, docs/ROADMAP.md.</a:t>
+            </a:r>
+          </a:p>
+          <a:p>
+            <a:r>
+              <a:t>Retained adapters preserve callback lifetimes and owner-thread execution. Isolated imports cannot use this bridge.</a:t>
+            </a:r>
+          </a:p>
+          <a:p>
+            <a:r>
+              <a:t>The 2026-09-16 evidence is a checkpoint; native and VM effect repairs and final integrated gates remain pending.</a:t>
             </a:r>
           </a:p>
         </p:txBody>
@@ -8375,7 +8375,7 @@
                 </a:solidFill>
                 <a:latin typeface="Arial"/>
               </a:rPr>
-              <a:t>4.1–4.5 history, and the work still ahead.</a:t>
+              <a:t>My 5.0 contract, and the work still ahead.</a:t>
             </a:r>
           </a:p>
         </p:txBody>
@@ -8555,7 +8555,7 @@
                 </a:solidFill>
                 <a:latin typeface="Arial"/>
               </a:rPr>
-              <a:t>4.5 SHIPPED</a:t>
+              <a:t>5.0 CANDIDATE</a:t>
             </a:r>
           </a:p>
         </p:txBody>
@@ -8589,7 +8589,7 @@
                 </a:solidFill>
                 <a:latin typeface="Arial"/>
               </a:rPr>
-              <a:t>verified NanoISA v2 (4.0)</a:t>
+              <a:t>enclosing-function return</a:t>
             </a:r>
           </a:p>
           <a:p>
@@ -8600,7 +8600,7 @@
                 </a:solidFill>
                 <a:latin typeface="Arial"/>
               </a:rPr>
-              <a:t>Forth Core evidence</a:t>
+              <a:t>dependency shadows</a:t>
             </a:r>
           </a:p>
           <a:p>
@@ -8611,7 +8611,7 @@
                 </a:solidFill>
                 <a:latin typeface="Arial"/>
               </a:rPr>
-              <a:t>NSI v0 + POSIX fabric</a:t>
+              <a:t>retained native callbacks</a:t>
             </a:r>
           </a:p>
           <a:p>
@@ -8622,7 +8622,7 @@
                 </a:solidFill>
                 <a:latin typeface="Arial"/>
               </a:rPr>
-              <a:t>capability APIs</a:t>
+              <a:t>module identity + caches</a:t>
             </a:r>
           </a:p>
           <a:p>
@@ -8633,7 +8633,7 @@
                 </a:solidFill>
                 <a:latin typeface="Arial"/>
               </a:rPr>
-              <a:t>isolated editor walker</a:t>
+              <a:t>expanded native lowering</a:t>
             </a:r>
           </a:p>
           <a:p>
@@ -8644,7 +8644,7 @@
                 </a:solidFill>
                 <a:latin typeface="Arial"/>
               </a:rPr>
-              <a:t>effects → policy + journal</a:t>
+              <a:t>laboratory frontends</a:t>
             </a:r>
           </a:p>
         </p:txBody>
@@ -8755,7 +8755,7 @@
                 </a:solidFill>
                 <a:latin typeface="Arial"/>
               </a:rPr>
-              <a:t>Standard System / INCLUDED</a:t>
+              <a:t>NanoISA-only bootstrap</a:t>
             </a:r>
           </a:p>
           <a:p>
@@ -8766,7 +8766,7 @@
                 </a:solidFill>
                 <a:latin typeface="Arial"/>
               </a:rPr>
-              <a:t>internationalized compiler</a:t>
+              <a:t>matching compiler .nvm</a:t>
             </a:r>
           </a:p>
           <a:p>
@@ -8777,7 +8777,7 @@
                 </a:solidFill>
                 <a:latin typeface="Arial"/>
               </a:rPr>
-              <a:t>GNU Emacs / a kernel</a:t>
+              <a:t>full backend parity</a:t>
             </a:r>
           </a:p>
           <a:p>
@@ -8788,7 +8788,7 @@
                 </a:solidFill>
                 <a:latin typeface="Arial"/>
               </a:rPr>
-              <a:t>CUDA or CPython wrap</a:t>
+              <a:t>complete ownership</a:t>
             </a:r>
           </a:p>
           <a:p>
@@ -8799,7 +8799,7 @@
                 </a:solidFill>
                 <a:latin typeface="Arial"/>
               </a:rPr>
-              <a:t>journal on every trap</a:t>
+              <a:t>isolated callback ABI</a:t>
             </a:r>
           </a:p>
           <a:p>
@@ -8810,7 +8810,7 @@
                 </a:solidFill>
                 <a:latin typeface="Arial"/>
               </a:rPr>
-              <a:t>5.0 One IR</a:t>
+              <a:t>production isolation</a:t>
             </a:r>
           </a:p>
         </p:txBody>
@@ -9008,7 +9008,7 @@
                 </a:solidFill>
                 <a:latin typeface="Courier New"/>
               </a:rPr>
-              <a:t>docs/RELEASE_4.5.md · userguide/guide/08_secure_runtime.md</a:t>
+              <a:t>docs/RELEASE_5.0.md · docs/CALLBACK_ABI.md</a:t>
             </a:r>
           </a:p>
         </p:txBody>

</xml_diff>

<commit_message>
Refresh 5.0 release edition with bounded integration evidence
</commit_message>
<xml_diff>
--- a/docs/presentation/nanolang-developer-overview.pptx
+++ b/docs/presentation/nanolang-developer-overview.pptx
@@ -522,7 +522,7 @@
           </a:p>
           <a:p>
             <a:r>
-              <a:t>I am a language with a runtime under development. This local draft is not a release or a production-isolation claim.</a:t>
+              <a:t>I am a language with a runtime under development. My release scope does not establish production isolation.</a:t>
             </a:r>
           </a:p>
           <a:p>
@@ -1007,7 +1007,7 @@
           </a:p>
           <a:p>
             <a:r>
-              <a:t>The 2026-09-16 evidence is a checkpoint; native and VM effect repairs and final integrated gates remain pending.</a:t>
+              <a:t>My 2026-09-16 checkpoints cover native and VM effects. Exact-commit clean-tree tests, platform CI and release acceptance are mandatory release gates.</a:t>
             </a:r>
           </a:p>
         </p:txBody>
@@ -4852,7 +4852,7 @@
                 </a:solidFill>
                 <a:latin typeface="Arial"/>
               </a:rPr>
-              <a:t>NANOLANG 5.0 DRAFT</a:t>
+              <a:t>NANOLANG 5.0</a:t>
             </a:r>
           </a:p>
         </p:txBody>
@@ -8409,7 +8409,7 @@
                 </a:solidFill>
                 <a:latin typeface="Arial"/>
               </a:rPr>
-              <a:t>The current 5.0 draft is not a release-readiness claim.</a:t>
+              <a:t>My language/runtime scope has explicit architecture limits.</a:t>
             </a:r>
           </a:p>
         </p:txBody>
@@ -8555,7 +8555,7 @@
                 </a:solidFill>
                 <a:latin typeface="Arial"/>
               </a:rPr>
-              <a:t>5.0 CANDIDATE</a:t>
+              <a:t>5.0 RELEASE SCOPE</a:t>
             </a:r>
           </a:p>
         </p:txBody>

</xml_diff>

<commit_message>
Audit native call argument evaluation order across backends (task_8bee9e1410ad44c2ab714b8dab98fdfa) (#359)
Landed by the MAC control plane after review approval.

- task: `task_8bee9e1410ad44c2ab714b8dab98fdfa`
- reviewed head: `94f872895a38369340dd7fa6ab688f9843ca7719`
- base at publication: `a06cbc118d260832342544e7badd7c7046ae0af6`
</commit_message>
<xml_diff>
--- a/docs/presentation/nanolang-developer-overview.pptx
+++ b/docs/presentation/nanolang-developer-overview.pptx
@@ -522,7 +522,7 @@
           </a:p>
           <a:p>
             <a:r>
-              <a:t>I am a language with a runtime under development. My release scope does not establish production isolation.</a:t>
+              <a:t>I am a language and a secure runtime. I do not claim a kernel.</a:t>
             </a:r>
           </a:p>
           <a:p>
@@ -597,22 +597,12 @@
           <a:lstStyle/>
           <a:p>
             <a:r>
-              <a:t>Authority: CONTRIBUTING.md, docs/CANONICAL_STYLE.md, tests/test_language_claims.py and examples/gcd.nano.</a:t>
-            </a:r>
-          </a:p>
-          <a:p>
-            <a:r>
-              <a:t>CPU exemptions include externs, main, generated lambdas and functions using extern calls. Explicit foreign-call shadows still run.</a:t>
-            </a:r>
-          </a:p>
-          <a:p>
-            <a:r>
-              <a:t>All three drivers select dependency shadows by default; --root-shadows-only opts out. Test processes have deadlines, not sandboxing.</a:t>
-            </a:r>
-          </a:p>
-          <a:p>
-            <a:r>
-              <a:t>I exercise nonnegative and zero gcd inputs here. These assertions are not a theorem for all integers.</a:t>
+              <a:t>Authority: CONTRIBUTING.md and the current test suites, counted at the v4.0.0 tag.</a:t>
+            </a:r>
+          </a:p>
+          <a:p>
+            <a:r>
+              <a:t>make test-verify-all-programs additionally verifies every program in tests/, because compiling is not verifying.</a:t>
             </a:r>
           </a:p>
         </p:txBody>
@@ -997,17 +987,17 @@
           <a:lstStyle/>
           <a:p>
             <a:r>
-              <a:t>Authority: docs/RELEASE_5.0.md, docs/CALLBACK_ABI.md, docs/ROADMAP.md.</a:t>
-            </a:r>
-          </a:p>
-          <a:p>
-            <a:r>
-              <a:t>Retained adapters preserve callback lifetimes and owner-thread execution. Isolated imports cannot use this bridge.</a:t>
-            </a:r>
-          </a:p>
-          <a:p>
-            <a:r>
-              <a:t>My 2026-09-16 checkpoints cover native and VM effects. Exact-commit clean-tree tests, platform CI and release acceptance are mandatory release gates.</a:t>
+              <a:t>Authority: docs/RELEASE_4.5.md, docs/ROADMAP.md, docs/FORTH_STANDARD_SYSTEM.md, docs/NSI_EFFECTS.md.</a:t>
+            </a:r>
+          </a:p>
+          <a:p>
+            <a:r>
+              <a:t>Catalogs and machine-draft guides exist. JSON/TOON stay English.</a:t>
+            </a:r>
+          </a:p>
+          <a:p>
+            <a:r>
+              <a:t>The live editor uses bin/nano_emacs_worker, not dlopen.</a:t>
             </a:r>
           </a:p>
         </p:txBody>
@@ -1152,12 +1142,17 @@
           </a:p>
           <a:p>
             <a:r>
-              <a:t>My project policy requires useful shadows. My compiler normally warns about missing tests, with documented exemptions.</a:t>
-            </a:r>
-          </a:p>
-          <a:p>
-            <a:r>
-              <a:t>A shadow tests its assertions; it does not prove every input. Compiler acceptance is not proof of correctness.</a:t>
+              <a:t>This slide carries the thesis. Everything after it is a mechanism serving this claim,</a:t>
+            </a:r>
+          </a:p>
+          <a:p>
+            <a:r>
+              <a:t>and a reader who does not accept it here will not care about the module format.</a:t>
+            </a:r>
+          </a:p>
+          <a:p>
+            <a:r>
+              <a:t>PROOF is not decoration: a function without a shadow test does not compile.</a:t>
             </a:r>
           </a:p>
         </p:txBody>
@@ -1457,12 +1452,7 @@
           </a:p>
           <a:p>
             <a:r>
-              <a:t>Imported signatures are declarations, not proof of foreign behavior. My abstract reference counter does not identify objects.</a:t>
-            </a:r>
-          </a:p>
-          <a:p>
-            <a:r>
-              <a:t>Formal NanoCore theorems and compiler correspondence are separate boundaries; see formal/README.md and docs/ROADMAP.md.</a:t>
+              <a:t>Every call now carries its signature, so a module is provable before it is linked.</a:t>
             </a:r>
           </a:p>
         </p:txBody>
@@ -1617,7 +1607,7 @@
           </a:p>
           <a:p>
             <a:r>
-              <a:t>I distinguish deterministic malformed-input testing, seed replay and mutation campaigns.</a:t>
+              <a:t>784 lines of fuzz and malformed-input tests were added in 4.0 across the six surfaces named here.</a:t>
             </a:r>
           </a:p>
           <a:p>
@@ -1702,7 +1692,7 @@
           </a:p>
           <a:p>
             <a:r>
-              <a:t>Shared handler bodies reduce duplication; execution equivalence still needs tests.</a:t>
+              <a:t>VM_CASE and VM_NEXT are the only difference, so the two strategies cannot drift in what an instruction does.</a:t>
             </a:r>
           </a:p>
           <a:p>
@@ -4852,7 +4842,7 @@
                 </a:solidFill>
                 <a:latin typeface="Arial"/>
               </a:rPr>
-              <a:t>NANOLANG 5.0</a:t>
+              <a:t>NANOLANG 4.5</a:t>
             </a:r>
           </a:p>
         </p:txBody>
@@ -4953,7 +4943,7 @@
                 </a:solidFill>
                 <a:latin typeface="Arial"/>
               </a:rPr>
-              <a:t>A developer's view of my syntax, compiler, NanoISA, and runtime foundations on POSIX.</a:t>
+              <a:t>A developer's view of my syntax, compiler, NanoISA, and the secure runtime I host on POSIX.</a:t>
             </a:r>
           </a:p>
         </p:txBody>
@@ -5082,7 +5072,7 @@
                 </a:solidFill>
                 <a:latin typeface="Arial"/>
               </a:rPr>
-              <a:t>I require useful shadows by project policy.</a:t>
+              <a:t>Every function carries a shadow test.</a:t>
             </a:r>
           </a:p>
         </p:txBody>
@@ -5116,7 +5106,7 @@
                 </a:solidFill>
                 <a:latin typeface="Arial"/>
               </a:rPr>
-              <a:t>Missing tests normally warn; exemptions are not evidence of correctness.</a:t>
+              <a:t>The test is an executable statement about behavior, not a coverage ornament.</a:t>
             </a:r>
           </a:p>
         </p:txBody>
@@ -5273,7 +5263,7 @@
                 </a:solidFill>
                 <a:latin typeface="Courier New"/>
               </a:rPr>
-              <a:t>    if (== b 0) { return a }</a:t>
+              <a:t>    ...</a:t>
             </a:r>
           </a:p>
           <a:p>
@@ -5284,9 +5274,10 @@
                 </a:solidFill>
                 <a:latin typeface="Courier New"/>
               </a:rPr>
-              <a:t>    return (gcd b (% a b))</a:t>
-            </a:r>
-          </a:p>
+              <a:t>}</a:t>
+            </a:r>
+          </a:p>
+          <a:p/>
           <a:p>
             <a:r>
               <a:rPr sz="1600" b="0">
@@ -5295,10 +5286,9 @@
                 </a:solidFill>
                 <a:latin typeface="Courier New"/>
               </a:rPr>
-              <a:t>}</a:t>
-            </a:r>
-          </a:p>
-          <a:p/>
+              <a:t>shadow gcd {</a:t>
+            </a:r>
+          </a:p>
           <a:p>
             <a:r>
               <a:rPr sz="1600" b="0">
@@ -5307,40 +5297,7 @@
                 </a:solidFill>
                 <a:latin typeface="Courier New"/>
               </a:rPr>
-              <a:t>shadow gcd {</a:t>
-            </a:r>
-          </a:p>
-          <a:p>
-            <a:r>
-              <a:rPr sz="1600" b="0">
-                <a:solidFill>
-                  <a:srgbClr val="EEF1F3"/>
-                </a:solidFill>
-                <a:latin typeface="Courier New"/>
-              </a:rPr>
               <a:t>    assert (== (gcd 48 18) 6)</a:t>
-            </a:r>
-          </a:p>
-          <a:p>
-            <a:r>
-              <a:rPr sz="1600" b="0">
-                <a:solidFill>
-                  <a:srgbClr val="EEF1F3"/>
-                </a:solidFill>
-                <a:latin typeface="Courier New"/>
-              </a:rPr>
-              <a:t>    assert (== (gcd 18 0) 18)</a:t>
-            </a:r>
-          </a:p>
-          <a:p>
-            <a:r>
-              <a:rPr sz="1600" b="0">
-                <a:solidFill>
-                  <a:srgbClr val="EEF1F3"/>
-                </a:solidFill>
-                <a:latin typeface="Courier New"/>
-              </a:rPr>
-              <a:t>    assert (== (gcd 0 0) 0)</a:t>
             </a:r>
           </a:p>
           <a:p>
@@ -5385,7 +5342,7 @@
                 </a:solidFill>
                 <a:latin typeface="Arial"/>
               </a:rPr>
-              <a:t>Useful tests: policy</a:t>
+              <a:t>2,632 NanoISA tests</a:t>
             </a:r>
           </a:p>
           <a:p>
@@ -5396,7 +5353,7 @@
                 </a:solidFill>
                 <a:latin typeface="Arial"/>
               </a:rPr>
-              <a:t>Missing tests: warnings</a:t>
+              <a:t>621 NanoVM tests</a:t>
             </a:r>
           </a:p>
           <a:p>
@@ -5407,7 +5364,7 @@
                 </a:solidFill>
                 <a:latin typeface="Arial"/>
               </a:rPr>
-              <a:t>Exemptions: documented</a:t>
+              <a:t>93 verifier tests</a:t>
             </a:r>
           </a:p>
           <a:p>
@@ -5418,52 +5375,7 @@
                 </a:solidFill>
                 <a:latin typeface="Arial"/>
               </a:rPr>
-              <a:t>Imports: tested by default</a:t>
-            </a:r>
-          </a:p>
-        </p:txBody>
-      </p:sp>
-      <p:sp>
-        <p:nvSpPr>
-          <p:cNvPr id="10" name="TextBox 9"/>
-          <p:cNvSpPr txBox="1"/>
-          <p:nvPr/>
-        </p:nvSpPr>
-        <p:spPr>
-          <a:xfrm>
-            <a:off x="6537960" y="4480560"/>
-            <a:ext cx="4297680" cy="640080"/>
-          </a:xfrm>
-          <a:prstGeom prst="rect">
-            <a:avLst/>
-          </a:prstGeom>
-          <a:noFill/>
-        </p:spPr>
-        <p:txBody>
-          <a:bodyPr wrap="square" lIns="45720" rIns="45720" tIns="27432" bIns="27432" anchor="t">
-            <a:spAutoFit/>
-          </a:bodyPr>
-          <a:lstStyle/>
-          <a:p>
-            <a:r>
-              <a:rPr sz="1400" b="0">
-                <a:solidFill>
-                  <a:srgbClr val="EEF1F3"/>
-                </a:solidFill>
-                <a:latin typeface="Arial"/>
-              </a:rPr>
-              <a:t>Separate test process;</a:t>
-            </a:r>
-          </a:p>
-          <a:p>
-            <a:r>
-              <a:rPr sz="1400" b="0">
-                <a:solidFill>
-                  <a:srgbClr val="EEF1F3"/>
-                </a:solidFill>
-                <a:latin typeface="Arial"/>
-              </a:rPr>
-              <a:t>source-only emission skips tests.</a:t>
+              <a:t>63 NanoVirt tests</a:t>
             </a:r>
           </a:p>
         </p:txBody>
@@ -6029,7 +5941,7 @@
                 </a:solidFill>
                 <a:latin typeface="Arial"/>
               </a:rPr>
-              <a:t>Historical 4.0 measurement: about 48x per crossing in the recorded setup.</a:t>
+              <a:t>isolation costs about 48x per crossing — which is what batching exists to amortize</a:t>
             </a:r>
           </a:p>
         </p:txBody>
@@ -6124,7 +6036,7 @@
                 </a:solidFill>
                 <a:latin typeface="Arial"/>
               </a:rPr>
-              <a:t>I collect tested reference cycles.</a:t>
+              <a:t>I collect cycles, so my backends agree about leaks.</a:t>
             </a:r>
           </a:p>
         </p:txBody>
@@ -6158,7 +6070,7 @@
                 </a:solidFill>
                 <a:latin typeface="Arial"/>
               </a:rPr>
-              <a:t>Cycle collection is not complete leak freedom or backend semantic equivalence.</a:t>
+              <a:t>Reference counting cannot reclaim a cycle, and a cycle is constructible from ordinary NanoLang.</a:t>
             </a:r>
           </a:p>
         </p:txBody>
@@ -7489,7 +7401,7 @@
                 </a:solidFill>
                 <a:latin typeface="Arial"/>
               </a:rPr>
-              <a:t>I build runtime foundations on an ordinary kernel.</a:t>
+              <a:t>I host a secure runtime on an ordinary kernel.</a:t>
             </a:r>
           </a:p>
         </p:txBody>
@@ -7523,7 +7435,7 @@
                 </a:solidFill>
                 <a:latin typeface="Arial"/>
               </a:rPr>
-              <a:t>Contracts, capabilities, a POSIX fabric, and a journal. Laboratory evidence, not production isolation.</a:t>
+              <a:t>Contracts, capabilities, a POSIX fabric, and a journal. Five layers. Not synonyms.</a:t>
             </a:r>
           </a:p>
         </p:txBody>
@@ -8147,7 +8059,7 @@
                 </a:solidFill>
                 <a:latin typeface="Arial"/>
               </a:rPr>
-              <a:t>checked handle</a:t>
+              <a:t>unforgeable</a:t>
             </a:r>
           </a:p>
         </p:txBody>
@@ -8375,7 +8287,7 @@
                 </a:solidFill>
                 <a:latin typeface="Arial"/>
               </a:rPr>
-              <a:t>My 5.0 contract, and the work still ahead.</a:t>
+              <a:t>4.1–4.5 shipped. Here is what I have not done.</a:t>
             </a:r>
           </a:p>
         </p:txBody>
@@ -8409,7 +8321,7 @@
                 </a:solidFill>
                 <a:latin typeface="Arial"/>
               </a:rPr>
-              <a:t>My language/runtime scope has explicit architecture limits.</a:t>
+              <a:t>One public tag from v4.0.0. Five product phases, not five GitHub Releases.</a:t>
             </a:r>
           </a:p>
         </p:txBody>
@@ -8555,7 +8467,7 @@
                 </a:solidFill>
                 <a:latin typeface="Arial"/>
               </a:rPr>
-              <a:t>5.0 RELEASE SCOPE</a:t>
+              <a:t>4.5 SHIPPED</a:t>
             </a:r>
           </a:p>
         </p:txBody>
@@ -8589,7 +8501,7 @@
                 </a:solidFill>
                 <a:latin typeface="Arial"/>
               </a:rPr>
-              <a:t>enclosing-function return</a:t>
+              <a:t>verified NanoISA v2 (4.0)</a:t>
             </a:r>
           </a:p>
           <a:p>
@@ -8600,7 +8512,7 @@
                 </a:solidFill>
                 <a:latin typeface="Arial"/>
               </a:rPr>
-              <a:t>dependency shadows</a:t>
+              <a:t>Forth Core evidence</a:t>
             </a:r>
           </a:p>
           <a:p>
@@ -8611,7 +8523,7 @@
                 </a:solidFill>
                 <a:latin typeface="Arial"/>
               </a:rPr>
-              <a:t>retained native callbacks</a:t>
+              <a:t>NSI v0 + POSIX fabric</a:t>
             </a:r>
           </a:p>
           <a:p>
@@ -8622,7 +8534,7 @@
                 </a:solidFill>
                 <a:latin typeface="Arial"/>
               </a:rPr>
-              <a:t>module identity + caches</a:t>
+              <a:t>unforgeable capabilities</a:t>
             </a:r>
           </a:p>
           <a:p>
@@ -8633,7 +8545,7 @@
                 </a:solidFill>
                 <a:latin typeface="Arial"/>
               </a:rPr>
-              <a:t>expanded native lowering</a:t>
+              <a:t>isolated editor walker</a:t>
             </a:r>
           </a:p>
           <a:p>
@@ -8644,7 +8556,7 @@
                 </a:solidFill>
                 <a:latin typeface="Arial"/>
               </a:rPr>
-              <a:t>laboratory frontends</a:t>
+              <a:t>effects → policy + journal</a:t>
             </a:r>
           </a:p>
         </p:txBody>
@@ -8755,7 +8667,7 @@
                 </a:solidFill>
                 <a:latin typeface="Arial"/>
               </a:rPr>
-              <a:t>NanoISA-only bootstrap</a:t>
+              <a:t>Standard System / INCLUDED</a:t>
             </a:r>
           </a:p>
           <a:p>
@@ -8766,7 +8678,7 @@
                 </a:solidFill>
                 <a:latin typeface="Arial"/>
               </a:rPr>
-              <a:t>matching compiler .nvm</a:t>
+              <a:t>internationalized compiler</a:t>
             </a:r>
           </a:p>
           <a:p>
@@ -8777,7 +8689,7 @@
                 </a:solidFill>
                 <a:latin typeface="Arial"/>
               </a:rPr>
-              <a:t>full backend parity</a:t>
+              <a:t>GNU Emacs / a kernel</a:t>
             </a:r>
           </a:p>
           <a:p>
@@ -8788,7 +8700,7 @@
                 </a:solidFill>
                 <a:latin typeface="Arial"/>
               </a:rPr>
-              <a:t>complete ownership</a:t>
+              <a:t>CUDA or CPython wrap</a:t>
             </a:r>
           </a:p>
           <a:p>
@@ -8799,7 +8711,7 @@
                 </a:solidFill>
                 <a:latin typeface="Arial"/>
               </a:rPr>
-              <a:t>isolated callback ABI</a:t>
+              <a:t>journal on every trap</a:t>
             </a:r>
           </a:p>
           <a:p>
@@ -8810,7 +8722,7 @@
                 </a:solidFill>
                 <a:latin typeface="Arial"/>
               </a:rPr>
-              <a:t>production isolation</a:t>
+              <a:t>5.0 One IR</a:t>
             </a:r>
           </a:p>
         </p:txBody>
@@ -9008,7 +8920,7 @@
                 </a:solidFill>
                 <a:latin typeface="Courier New"/>
               </a:rPr>
-              <a:t>docs/RELEASE_5.0.md · docs/CALLBACK_ABI.md</a:t>
+              <a:t>docs/RELEASE_4.5.md · userguide/guide/08_secure_runtime.md</a:t>
             </a:r>
           </a:p>
         </p:txBody>
@@ -9172,7 +9084,7 @@
                 </a:solidFill>
                 <a:latin typeface="Arial"/>
               </a:rPr>
-              <a:t>I make calls and test obligations explicit.</a:t>
+              <a:t>Machines write code now. The bottleneck is checking it.</a:t>
             </a:r>
           </a:p>
         </p:txBody>
@@ -9206,7 +9118,7 @@
                 </a:solidFill>
                 <a:latin typeface="Arial"/>
               </a:rPr>
-              <a:t>I recommend canonical forms; my parser also accepts legacy syntax.</a:t>
+              <a:t>So I refuse ambiguity: one canonical form, explicit boundaries, and evidence required to compile.</a:t>
             </a:r>
           </a:p>
         </p:txBody>
@@ -9574,7 +9486,7 @@
                 </a:solidFill>
                 <a:latin typeface="Arial"/>
               </a:rPr>
-              <a:t>TESTS</a:t>
+              <a:t>PROOF</a:t>
             </a:r>
           </a:p>
         </p:txBody>
@@ -9608,7 +9520,7 @@
                 </a:solidFill>
                 <a:latin typeface="Courier New"/>
               </a:rPr>
-              <a:t>shadow gcd { ... }</a:t>
+              <a:t>shadow fn { ... }</a:t>
             </a:r>
           </a:p>
         </p:txBody>
@@ -11520,7 +11432,7 @@
                 </a:solidFill>
                 <a:latin typeface="Arial"/>
               </a:rPr>
-              <a:t>My verifier checks modeled invariants before execution.</a:t>
+              <a:t>My verifier proves a program before it runs.</a:t>
             </a:r>
           </a:p>
         </p:txBody>
@@ -11554,7 +11466,7 @@
                 </a:solidFill>
                 <a:latin typeface="Arial"/>
               </a:rPr>
-              <a:t>These checks are not whole-program proof or complete source ownership.</a:t>
+              <a:t>Each property below was a run-time trap. Now it is a rejection.</a:t>
             </a:r>
           </a:p>
         </p:txBody>
@@ -11845,7 +11757,7 @@
                 </a:solidFill>
                 <a:latin typeface="Arial"/>
               </a:rPr>
-              <a:t>known contradictions are refused; unknown stays unknown</a:t>
+              <a:t>a known contradiction is refused; unknown never fails</a:t>
             </a:r>
           </a:p>
         </p:txBody>
@@ -12144,7 +12056,7 @@
                 </a:solidFill>
                 <a:latin typeface="Arial"/>
               </a:rPr>
-              <a:t>reference balance</a:t>
+              <a:t>ownership</a:t>
             </a:r>
           </a:p>
         </p:txBody>
@@ -12178,7 +12090,7 @@
                 </a:solidFill>
                 <a:latin typeface="Arial"/>
               </a:rPr>
-              <a:t>explicit retain/release counts, not object identity</a:t>
+              <a:t>retain and release must balance on every path</a:t>
             </a:r>
           </a:p>
         </p:txBody>
@@ -12815,7 +12727,7 @@
                 </a:solidFill>
                 <a:latin typeface="Arial"/>
               </a:rPr>
-              <a:t>My verifier and parsers have malformed-input tests; their coverage is not universal.</a:t>
+              <a:t>The verifier is one defence. The parsers underneath it are the other, and they are fuzzed.</a:t>
             </a:r>
           </a:p>
         </p:txBody>
@@ -13403,7 +13315,7 @@
         <p:spPr>
           <a:xfrm>
             <a:off x="1051560" y="3794760"/>
-            <a:ext cx="10058400" cy="320040"/>
+            <a:ext cx="4572000" cy="320040"/>
           </a:xfrm>
           <a:prstGeom prst="rect">
             <a:avLst/>
@@ -13423,7 +13335,7 @@
                 </a:solidFill>
                 <a:latin typeface="Courier New"/>
               </a:rPr>
-              <a:t>offset &gt; total || size &gt; total - offset</a:t>
+              <a:t>size &gt; total - offset</a:t>
             </a:r>
           </a:p>
         </p:txBody>
@@ -13431,6 +13343,40 @@
       <p:sp>
         <p:nvSpPr>
           <p:cNvPr id="21" name="TextBox 20"/>
+          <p:cNvSpPr txBox="1"/>
+          <p:nvPr/>
+        </p:nvSpPr>
+        <p:spPr>
+          <a:xfrm>
+            <a:off x="6035040" y="3840480"/>
+            <a:ext cx="5120640" cy="274320"/>
+          </a:xfrm>
+          <a:prstGeom prst="rect">
+            <a:avLst/>
+          </a:prstGeom>
+          <a:noFill/>
+        </p:spPr>
+        <p:txBody>
+          <a:bodyPr wrap="square" lIns="45720" rIns="45720" tIns="27432" bIns="27432" anchor="t">
+            <a:spAutoFit/>
+          </a:bodyPr>
+          <a:lstStyle/>
+          <a:p>
+            <a:r>
+              <a:rPr sz="1500" b="1">
+                <a:solidFill>
+                  <a:srgbClr val="65707C"/>
+                </a:solidFill>
+                <a:latin typeface="Courier New"/>
+              </a:rPr>
+              <a:t>never  offset + size &gt; total</a:t>
+            </a:r>
+          </a:p>
+        </p:txBody>
+      </p:sp>
+      <p:sp>
+        <p:nvSpPr>
+          <p:cNvPr id="22" name="TextBox 21"/>
           <p:cNvSpPr txBox="1"/>
           <p:nvPr/>
         </p:nvSpPr>
@@ -13457,14 +13403,14 @@
                 </a:solidFill>
                 <a:latin typeface="Arial"/>
               </a:rPr>
-              <a:t>I bound the offset before subtracting. An unchecked addition or subtraction can wrap. My deterministic malformed-input suites exercise these parsing boundaries; passing their cases is not proof for arbitrary bytes or an unlimited fuzzing campaign.</a:t>
-            </a:r>
-          </a:p>
-        </p:txBody>
-      </p:sp>
-      <p:sp>
-        <p:nvSpPr>
-          <p:cNvPr id="22" name="TextBox 21"/>
+              <a:t>The second form wraps, so an offset near the top of the range passes the check that exists to stop it. Every range in the v2 decoder is written as the first form. Argument limits agree across imports, traps, direct FFI and the co-process, so no path is the lenient one.</a:t>
+            </a:r>
+          </a:p>
+        </p:txBody>
+      </p:sp>
+      <p:sp>
+        <p:nvSpPr>
+          <p:cNvPr id="23" name="TextBox 22"/>
           <p:cNvSpPr txBox="1"/>
           <p:nvPr/>
         </p:nvSpPr>
@@ -13492,7 +13438,7 @@
                 </a:solidFill>
                 <a:latin typeface="Courier New"/>
               </a:rPr>
-              <a:t>Malformed-input tests are evidence, not universal safety proofs.</a:t>
+              <a:t>784 lines of fuzz and malformed-input tests, added in 4.0, across all six</a:t>
             </a:r>
           </a:p>
         </p:txBody>
@@ -13621,7 +13567,7 @@
                 </a:solidFill>
                 <a:latin typeface="Arial"/>
               </a:rPr>
-              <a:t>Historical 4.0 measurement: one handler body, two dispatch strategies.</a:t>
+              <a:t>One copy of 161 handlers, reached two ways. Adopted on measurement, not principle.</a:t>
             </a:r>
           </a:p>
         </p:txBody>

</xml_diff>

<commit_message>
fix: restore released compiler tree and full 5.0 acceptance scope
</commit_message>
<xml_diff>
--- a/docs/presentation/nanolang-developer-overview.pptx
+++ b/docs/presentation/nanolang-developer-overview.pptx
@@ -522,7 +522,7 @@
           </a:p>
           <a:p>
             <a:r>
-              <a:t>I am a language and a secure runtime. I do not claim a kernel.</a:t>
+              <a:t>I am a language with a runtime under development. My release scope does not establish production isolation.</a:t>
             </a:r>
           </a:p>
           <a:p>
@@ -597,12 +597,22 @@
           <a:lstStyle/>
           <a:p>
             <a:r>
-              <a:t>Authority: CONTRIBUTING.md and the current test suites, counted at the v4.0.0 tag.</a:t>
-            </a:r>
-          </a:p>
-          <a:p>
-            <a:r>
-              <a:t>make test-verify-all-programs additionally verifies every program in tests/, because compiling is not verifying.</a:t>
+              <a:t>Authority: CONTRIBUTING.md, docs/CANONICAL_STYLE.md, tests/test_language_claims.py and examples/gcd.nano.</a:t>
+            </a:r>
+          </a:p>
+          <a:p>
+            <a:r>
+              <a:t>CPU exemptions include externs, main, generated lambdas and functions using extern calls. Explicit foreign-call shadows still run.</a:t>
+            </a:r>
+          </a:p>
+          <a:p>
+            <a:r>
+              <a:t>All three drivers select dependency shadows by default; --root-shadows-only opts out. Test processes have deadlines, not sandboxing.</a:t>
+            </a:r>
+          </a:p>
+          <a:p>
+            <a:r>
+              <a:t>I exercise nonnegative and zero gcd inputs here. These assertions are not a theorem for all integers.</a:t>
             </a:r>
           </a:p>
         </p:txBody>
@@ -987,17 +997,17 @@
           <a:lstStyle/>
           <a:p>
             <a:r>
-              <a:t>Authority: docs/RELEASE_4.5.md, docs/ROADMAP.md, docs/FORTH_STANDARD_SYSTEM.md, docs/NSI_EFFECTS.md.</a:t>
-            </a:r>
-          </a:p>
-          <a:p>
-            <a:r>
-              <a:t>Catalogs and machine-draft guides exist. JSON/TOON stay English.</a:t>
-            </a:r>
-          </a:p>
-          <a:p>
-            <a:r>
-              <a:t>The live editor uses bin/nano_emacs_worker, not dlopen.</a:t>
+              <a:t>Authority: docs/RELEASE_5.0.md, docs/CALLBACK_ABI.md, docs/ROADMAP.md.</a:t>
+            </a:r>
+          </a:p>
+          <a:p>
+            <a:r>
+              <a:t>Retained adapters preserve callback lifetimes and owner-thread execution. Isolated imports cannot use this bridge.</a:t>
+            </a:r>
+          </a:p>
+          <a:p>
+            <a:r>
+              <a:t>My 2026-09-16 checkpoints cover native and VM effects. Exact-commit clean-tree tests, platform CI and release acceptance are mandatory release gates.</a:t>
             </a:r>
           </a:p>
         </p:txBody>
@@ -1142,17 +1152,12 @@
           </a:p>
           <a:p>
             <a:r>
-              <a:t>This slide carries the thesis. Everything after it is a mechanism serving this claim,</a:t>
-            </a:r>
-          </a:p>
-          <a:p>
-            <a:r>
-              <a:t>and a reader who does not accept it here will not care about the module format.</a:t>
-            </a:r>
-          </a:p>
-          <a:p>
-            <a:r>
-              <a:t>PROOF is not decoration: a function without a shadow test does not compile.</a:t>
+              <a:t>My project policy requires useful shadows. My compiler normally warns about missing tests, with documented exemptions.</a:t>
+            </a:r>
+          </a:p>
+          <a:p>
+            <a:r>
+              <a:t>A shadow tests its assertions; it does not prove every input. Compiler acceptance is not proof of correctness.</a:t>
             </a:r>
           </a:p>
         </p:txBody>
@@ -1452,7 +1457,12 @@
           </a:p>
           <a:p>
             <a:r>
-              <a:t>Every call now carries its signature, so a module is provable before it is linked.</a:t>
+              <a:t>Imported signatures are declarations, not proof of foreign behavior. My abstract reference counter does not identify objects.</a:t>
+            </a:r>
+          </a:p>
+          <a:p>
+            <a:r>
+              <a:t>Formal NanoCore theorems and compiler correspondence are separate boundaries; see formal/README.md and docs/ROADMAP.md.</a:t>
             </a:r>
           </a:p>
         </p:txBody>
@@ -1607,7 +1617,7 @@
           </a:p>
           <a:p>
             <a:r>
-              <a:t>784 lines of fuzz and malformed-input tests were added in 4.0 across the six surfaces named here.</a:t>
+              <a:t>I distinguish deterministic malformed-input testing, seed replay and mutation campaigns.</a:t>
             </a:r>
           </a:p>
           <a:p>
@@ -1692,7 +1702,7 @@
           </a:p>
           <a:p>
             <a:r>
-              <a:t>VM_CASE and VM_NEXT are the only difference, so the two strategies cannot drift in what an instruction does.</a:t>
+              <a:t>Shared handler bodies reduce duplication; execution equivalence still needs tests.</a:t>
             </a:r>
           </a:p>
           <a:p>
@@ -4842,7 +4852,7 @@
                 </a:solidFill>
                 <a:latin typeface="Arial"/>
               </a:rPr>
-              <a:t>NANOLANG 4.5</a:t>
+              <a:t>NANOLANG 5.0</a:t>
             </a:r>
           </a:p>
         </p:txBody>
@@ -4943,7 +4953,7 @@
                 </a:solidFill>
                 <a:latin typeface="Arial"/>
               </a:rPr>
-              <a:t>A developer's view of my syntax, compiler, NanoISA, and the secure runtime I host on POSIX.</a:t>
+              <a:t>A developer's view of my syntax, compiler, NanoISA, and runtime foundations on POSIX.</a:t>
             </a:r>
           </a:p>
         </p:txBody>
@@ -5072,7 +5082,7 @@
                 </a:solidFill>
                 <a:latin typeface="Arial"/>
               </a:rPr>
-              <a:t>Every function carries a shadow test.</a:t>
+              <a:t>I require useful shadows by project policy.</a:t>
             </a:r>
           </a:p>
         </p:txBody>
@@ -5106,7 +5116,7 @@
                 </a:solidFill>
                 <a:latin typeface="Arial"/>
               </a:rPr>
-              <a:t>The test is an executable statement about behavior, not a coverage ornament.</a:t>
+              <a:t>Missing tests normally warn; exemptions are not evidence of correctness.</a:t>
             </a:r>
           </a:p>
         </p:txBody>
@@ -5263,7 +5273,7 @@
                 </a:solidFill>
                 <a:latin typeface="Courier New"/>
               </a:rPr>
-              <a:t>    ...</a:t>
+              <a:t>    if (== b 0) { return a }</a:t>
             </a:r>
           </a:p>
           <a:p>
@@ -5274,6 +5284,17 @@
                 </a:solidFill>
                 <a:latin typeface="Courier New"/>
               </a:rPr>
+              <a:t>    return (gcd b (% a b))</a:t>
+            </a:r>
+          </a:p>
+          <a:p>
+            <a:r>
+              <a:rPr sz="1600" b="0">
+                <a:solidFill>
+                  <a:srgbClr val="EEF1F3"/>
+                </a:solidFill>
+                <a:latin typeface="Courier New"/>
+              </a:rPr>
               <a:t>}</a:t>
             </a:r>
           </a:p>
@@ -5298,6 +5319,28 @@
                 <a:latin typeface="Courier New"/>
               </a:rPr>
               <a:t>    assert (== (gcd 48 18) 6)</a:t>
+            </a:r>
+          </a:p>
+          <a:p>
+            <a:r>
+              <a:rPr sz="1600" b="0">
+                <a:solidFill>
+                  <a:srgbClr val="EEF1F3"/>
+                </a:solidFill>
+                <a:latin typeface="Courier New"/>
+              </a:rPr>
+              <a:t>    assert (== (gcd 18 0) 18)</a:t>
+            </a:r>
+          </a:p>
+          <a:p>
+            <a:r>
+              <a:rPr sz="1600" b="0">
+                <a:solidFill>
+                  <a:srgbClr val="EEF1F3"/>
+                </a:solidFill>
+                <a:latin typeface="Courier New"/>
+              </a:rPr>
+              <a:t>    assert (== (gcd 0 0) 0)</a:t>
             </a:r>
           </a:p>
           <a:p>
@@ -5342,7 +5385,7 @@
                 </a:solidFill>
                 <a:latin typeface="Arial"/>
               </a:rPr>
-              <a:t>2,632 NanoISA tests</a:t>
+              <a:t>Useful tests: policy</a:t>
             </a:r>
           </a:p>
           <a:p>
@@ -5353,7 +5396,7 @@
                 </a:solidFill>
                 <a:latin typeface="Arial"/>
               </a:rPr>
-              <a:t>621 NanoVM tests</a:t>
+              <a:t>Missing tests: warnings</a:t>
             </a:r>
           </a:p>
           <a:p>
@@ -5364,7 +5407,7 @@
                 </a:solidFill>
                 <a:latin typeface="Arial"/>
               </a:rPr>
-              <a:t>93 verifier tests</a:t>
+              <a:t>Exemptions: documented</a:t>
             </a:r>
           </a:p>
           <a:p>
@@ -5375,7 +5418,52 @@
                 </a:solidFill>
                 <a:latin typeface="Arial"/>
               </a:rPr>
-              <a:t>63 NanoVirt tests</a:t>
+              <a:t>Imports: tested by default</a:t>
+            </a:r>
+          </a:p>
+        </p:txBody>
+      </p:sp>
+      <p:sp>
+        <p:nvSpPr>
+          <p:cNvPr id="10" name="TextBox 9"/>
+          <p:cNvSpPr txBox="1"/>
+          <p:nvPr/>
+        </p:nvSpPr>
+        <p:spPr>
+          <a:xfrm>
+            <a:off x="6537960" y="4480560"/>
+            <a:ext cx="4297680" cy="640080"/>
+          </a:xfrm>
+          <a:prstGeom prst="rect">
+            <a:avLst/>
+          </a:prstGeom>
+          <a:noFill/>
+        </p:spPr>
+        <p:txBody>
+          <a:bodyPr wrap="square" lIns="45720" rIns="45720" tIns="27432" bIns="27432" anchor="t">
+            <a:spAutoFit/>
+          </a:bodyPr>
+          <a:lstStyle/>
+          <a:p>
+            <a:r>
+              <a:rPr sz="1400" b="0">
+                <a:solidFill>
+                  <a:srgbClr val="EEF1F3"/>
+                </a:solidFill>
+                <a:latin typeface="Arial"/>
+              </a:rPr>
+              <a:t>Separate test process;</a:t>
+            </a:r>
+          </a:p>
+          <a:p>
+            <a:r>
+              <a:rPr sz="1400" b="0">
+                <a:solidFill>
+                  <a:srgbClr val="EEF1F3"/>
+                </a:solidFill>
+                <a:latin typeface="Arial"/>
+              </a:rPr>
+              <a:t>source-only emission skips tests.</a:t>
             </a:r>
           </a:p>
         </p:txBody>
@@ -5941,7 +6029,7 @@
                 </a:solidFill>
                 <a:latin typeface="Arial"/>
               </a:rPr>
-              <a:t>isolation costs about 48x per crossing — which is what batching exists to amortize</a:t>
+              <a:t>Historical 4.0 measurement: about 48x per crossing in the recorded setup.</a:t>
             </a:r>
           </a:p>
         </p:txBody>
@@ -6036,7 +6124,7 @@
                 </a:solidFill>
                 <a:latin typeface="Arial"/>
               </a:rPr>
-              <a:t>I collect cycles, so my backends agree about leaks.</a:t>
+              <a:t>I collect tested reference cycles.</a:t>
             </a:r>
           </a:p>
         </p:txBody>
@@ -6070,7 +6158,7 @@
                 </a:solidFill>
                 <a:latin typeface="Arial"/>
               </a:rPr>
-              <a:t>Reference counting cannot reclaim a cycle, and a cycle is constructible from ordinary NanoLang.</a:t>
+              <a:t>Cycle collection is not complete leak freedom or backend semantic equivalence.</a:t>
             </a:r>
           </a:p>
         </p:txBody>
@@ -7401,7 +7489,7 @@
                 </a:solidFill>
                 <a:latin typeface="Arial"/>
               </a:rPr>
-              <a:t>I host a secure runtime on an ordinary kernel.</a:t>
+              <a:t>I build runtime foundations on an ordinary kernel.</a:t>
             </a:r>
           </a:p>
         </p:txBody>
@@ -7435,7 +7523,7 @@
                 </a:solidFill>
                 <a:latin typeface="Arial"/>
               </a:rPr>
-              <a:t>Contracts, capabilities, a POSIX fabric, and a journal. Five layers. Not synonyms.</a:t>
+              <a:t>Contracts, capabilities, a POSIX fabric, and a journal. Laboratory evidence, not production isolation.</a:t>
             </a:r>
           </a:p>
         </p:txBody>
@@ -8059,7 +8147,7 @@
                 </a:solidFill>
                 <a:latin typeface="Arial"/>
               </a:rPr>
-              <a:t>unforgeable</a:t>
+              <a:t>checked handle</a:t>
             </a:r>
           </a:p>
         </p:txBody>
@@ -8287,7 +8375,7 @@
                 </a:solidFill>
                 <a:latin typeface="Arial"/>
               </a:rPr>
-              <a:t>4.1–4.5 shipped. Here is what I have not done.</a:t>
+              <a:t>My 5.0 contract, and the work still ahead.</a:t>
             </a:r>
           </a:p>
         </p:txBody>
@@ -8321,7 +8409,7 @@
                 </a:solidFill>
                 <a:latin typeface="Arial"/>
               </a:rPr>
-              <a:t>One public tag from v4.0.0. Five product phases, not five GitHub Releases.</a:t>
+              <a:t>My language/runtime scope has explicit architecture limits.</a:t>
             </a:r>
           </a:p>
         </p:txBody>
@@ -8467,7 +8555,7 @@
                 </a:solidFill>
                 <a:latin typeface="Arial"/>
               </a:rPr>
-              <a:t>4.5 SHIPPED</a:t>
+              <a:t>5.0 RELEASE SCOPE</a:t>
             </a:r>
           </a:p>
         </p:txBody>
@@ -8501,7 +8589,7 @@
                 </a:solidFill>
                 <a:latin typeface="Arial"/>
               </a:rPr>
-              <a:t>verified NanoISA v2 (4.0)</a:t>
+              <a:t>enclosing-function return</a:t>
             </a:r>
           </a:p>
           <a:p>
@@ -8512,7 +8600,7 @@
                 </a:solidFill>
                 <a:latin typeface="Arial"/>
               </a:rPr>
-              <a:t>Forth Core evidence</a:t>
+              <a:t>dependency shadows</a:t>
             </a:r>
           </a:p>
           <a:p>
@@ -8523,7 +8611,7 @@
                 </a:solidFill>
                 <a:latin typeface="Arial"/>
               </a:rPr>
-              <a:t>NSI v0 + POSIX fabric</a:t>
+              <a:t>retained native callbacks</a:t>
             </a:r>
           </a:p>
           <a:p>
@@ -8534,7 +8622,7 @@
                 </a:solidFill>
                 <a:latin typeface="Arial"/>
               </a:rPr>
-              <a:t>unforgeable capabilities</a:t>
+              <a:t>module identity + caches</a:t>
             </a:r>
           </a:p>
           <a:p>
@@ -8545,7 +8633,7 @@
                 </a:solidFill>
                 <a:latin typeface="Arial"/>
               </a:rPr>
-              <a:t>isolated editor walker</a:t>
+              <a:t>expanded native lowering</a:t>
             </a:r>
           </a:p>
           <a:p>
@@ -8556,7 +8644,7 @@
                 </a:solidFill>
                 <a:latin typeface="Arial"/>
               </a:rPr>
-              <a:t>effects → policy + journal</a:t>
+              <a:t>laboratory frontends</a:t>
             </a:r>
           </a:p>
         </p:txBody>
@@ -8667,7 +8755,7 @@
                 </a:solidFill>
                 <a:latin typeface="Arial"/>
               </a:rPr>
-              <a:t>Standard System / INCLUDED</a:t>
+              <a:t>NanoISA-only bootstrap</a:t>
             </a:r>
           </a:p>
           <a:p>
@@ -8678,7 +8766,7 @@
                 </a:solidFill>
                 <a:latin typeface="Arial"/>
               </a:rPr>
-              <a:t>internationalized compiler</a:t>
+              <a:t>matching compiler .nvm</a:t>
             </a:r>
           </a:p>
           <a:p>
@@ -8689,7 +8777,7 @@
                 </a:solidFill>
                 <a:latin typeface="Arial"/>
               </a:rPr>
-              <a:t>GNU Emacs / a kernel</a:t>
+              <a:t>full backend parity</a:t>
             </a:r>
           </a:p>
           <a:p>
@@ -8700,7 +8788,7 @@
                 </a:solidFill>
                 <a:latin typeface="Arial"/>
               </a:rPr>
-              <a:t>CUDA or CPython wrap</a:t>
+              <a:t>complete ownership</a:t>
             </a:r>
           </a:p>
           <a:p>
@@ -8711,7 +8799,7 @@
                 </a:solidFill>
                 <a:latin typeface="Arial"/>
               </a:rPr>
-              <a:t>journal on every trap</a:t>
+              <a:t>isolated callback ABI</a:t>
             </a:r>
           </a:p>
           <a:p>
@@ -8722,7 +8810,7 @@
                 </a:solidFill>
                 <a:latin typeface="Arial"/>
               </a:rPr>
-              <a:t>5.0 One IR</a:t>
+              <a:t>production isolation</a:t>
             </a:r>
           </a:p>
         </p:txBody>
@@ -8920,7 +9008,7 @@
                 </a:solidFill>
                 <a:latin typeface="Courier New"/>
               </a:rPr>
-              <a:t>docs/RELEASE_4.5.md · userguide/guide/08_secure_runtime.md</a:t>
+              <a:t>docs/RELEASE_5.0.md · docs/CALLBACK_ABI.md</a:t>
             </a:r>
           </a:p>
         </p:txBody>
@@ -9084,7 +9172,7 @@
                 </a:solidFill>
                 <a:latin typeface="Arial"/>
               </a:rPr>
-              <a:t>Machines write code now. The bottleneck is checking it.</a:t>
+              <a:t>I make calls and test obligations explicit.</a:t>
             </a:r>
           </a:p>
         </p:txBody>
@@ -9118,7 +9206,7 @@
                 </a:solidFill>
                 <a:latin typeface="Arial"/>
               </a:rPr>
-              <a:t>So I refuse ambiguity: one canonical form, explicit boundaries, and evidence required to compile.</a:t>
+              <a:t>I recommend canonical forms; my parser also accepts legacy syntax.</a:t>
             </a:r>
           </a:p>
         </p:txBody>
@@ -9486,7 +9574,7 @@
                 </a:solidFill>
                 <a:latin typeface="Arial"/>
               </a:rPr>
-              <a:t>PROOF</a:t>
+              <a:t>TESTS</a:t>
             </a:r>
           </a:p>
         </p:txBody>
@@ -9520,7 +9608,7 @@
                 </a:solidFill>
                 <a:latin typeface="Courier New"/>
               </a:rPr>
-              <a:t>shadow fn { ... }</a:t>
+              <a:t>shadow gcd { ... }</a:t>
             </a:r>
           </a:p>
         </p:txBody>
@@ -11432,7 +11520,7 @@
                 </a:solidFill>
                 <a:latin typeface="Arial"/>
               </a:rPr>
-              <a:t>My verifier proves a program before it runs.</a:t>
+              <a:t>My verifier checks modeled invariants before execution.</a:t>
             </a:r>
           </a:p>
         </p:txBody>
@@ -11466,7 +11554,7 @@
                 </a:solidFill>
                 <a:latin typeface="Arial"/>
               </a:rPr>
-              <a:t>Each property below was a run-time trap. Now it is a rejection.</a:t>
+              <a:t>These checks are not whole-program proof or complete source ownership.</a:t>
             </a:r>
           </a:p>
         </p:txBody>
@@ -11757,7 +11845,7 @@
                 </a:solidFill>
                 <a:latin typeface="Arial"/>
               </a:rPr>
-              <a:t>a known contradiction is refused; unknown never fails</a:t>
+              <a:t>known contradictions are refused; unknown stays unknown</a:t>
             </a:r>
           </a:p>
         </p:txBody>
@@ -12056,7 +12144,7 @@
                 </a:solidFill>
                 <a:latin typeface="Arial"/>
               </a:rPr>
-              <a:t>ownership</a:t>
+              <a:t>reference balance</a:t>
             </a:r>
           </a:p>
         </p:txBody>
@@ -12090,7 +12178,7 @@
                 </a:solidFill>
                 <a:latin typeface="Arial"/>
               </a:rPr>
-              <a:t>retain and release must balance on every path</a:t>
+              <a:t>explicit retain/release counts, not object identity</a:t>
             </a:r>
           </a:p>
         </p:txBody>
@@ -12727,7 +12815,7 @@
                 </a:solidFill>
                 <a:latin typeface="Arial"/>
               </a:rPr>
-              <a:t>The verifier is one defence. The parsers underneath it are the other, and they are fuzzed.</a:t>
+              <a:t>My verifier and parsers have malformed-input tests; their coverage is not universal.</a:t>
             </a:r>
           </a:p>
         </p:txBody>
@@ -13315,7 +13403,7 @@
         <p:spPr>
           <a:xfrm>
             <a:off x="1051560" y="3794760"/>
-            <a:ext cx="4572000" cy="320040"/>
+            <a:ext cx="10058400" cy="320040"/>
           </a:xfrm>
           <a:prstGeom prst="rect">
             <a:avLst/>
@@ -13335,7 +13423,7 @@
                 </a:solidFill>
                 <a:latin typeface="Courier New"/>
               </a:rPr>
-              <a:t>size &gt; total - offset</a:t>
+              <a:t>offset &gt; total || size &gt; total - offset</a:t>
             </a:r>
           </a:p>
         </p:txBody>
@@ -13343,40 +13431,6 @@
       <p:sp>
         <p:nvSpPr>
           <p:cNvPr id="21" name="TextBox 20"/>
-          <p:cNvSpPr txBox="1"/>
-          <p:nvPr/>
-        </p:nvSpPr>
-        <p:spPr>
-          <a:xfrm>
-            <a:off x="6035040" y="3840480"/>
-            <a:ext cx="5120640" cy="274320"/>
-          </a:xfrm>
-          <a:prstGeom prst="rect">
-            <a:avLst/>
-          </a:prstGeom>
-          <a:noFill/>
-        </p:spPr>
-        <p:txBody>
-          <a:bodyPr wrap="square" lIns="45720" rIns="45720" tIns="27432" bIns="27432" anchor="t">
-            <a:spAutoFit/>
-          </a:bodyPr>
-          <a:lstStyle/>
-          <a:p>
-            <a:r>
-              <a:rPr sz="1500" b="1">
-                <a:solidFill>
-                  <a:srgbClr val="65707C"/>
-                </a:solidFill>
-                <a:latin typeface="Courier New"/>
-              </a:rPr>
-              <a:t>never  offset + size &gt; total</a:t>
-            </a:r>
-          </a:p>
-        </p:txBody>
-      </p:sp>
-      <p:sp>
-        <p:nvSpPr>
-          <p:cNvPr id="22" name="TextBox 21"/>
           <p:cNvSpPr txBox="1"/>
           <p:nvPr/>
         </p:nvSpPr>
@@ -13403,14 +13457,14 @@
                 </a:solidFill>
                 <a:latin typeface="Arial"/>
               </a:rPr>
-              <a:t>The second form wraps, so an offset near the top of the range passes the check that exists to stop it. Every range in the v2 decoder is written as the first form. Argument limits agree across imports, traps, direct FFI and the co-process, so no path is the lenient one.</a:t>
-            </a:r>
-          </a:p>
-        </p:txBody>
-      </p:sp>
-      <p:sp>
-        <p:nvSpPr>
-          <p:cNvPr id="23" name="TextBox 22"/>
+              <a:t>I bound the offset before subtracting. An unchecked addition or subtraction can wrap. My deterministic malformed-input suites exercise these parsing boundaries; passing their cases is not proof for arbitrary bytes or an unlimited fuzzing campaign.</a:t>
+            </a:r>
+          </a:p>
+        </p:txBody>
+      </p:sp>
+      <p:sp>
+        <p:nvSpPr>
+          <p:cNvPr id="22" name="TextBox 21"/>
           <p:cNvSpPr txBox="1"/>
           <p:nvPr/>
         </p:nvSpPr>
@@ -13438,7 +13492,7 @@
                 </a:solidFill>
                 <a:latin typeface="Courier New"/>
               </a:rPr>
-              <a:t>784 lines of fuzz and malformed-input tests, added in 4.0, across all six</a:t>
+              <a:t>Malformed-input tests are evidence, not universal safety proofs.</a:t>
             </a:r>
           </a:p>
         </p:txBody>
@@ -13567,7 +13621,7 @@
                 </a:solidFill>
                 <a:latin typeface="Arial"/>
               </a:rPr>
-              <a:t>One copy of 161 handlers, reached two ways. Adopted on measurement, not principle.</a:t>
+              <a:t>Historical 4.0 measurement: one handler body, two dispatch strategies.</a:t>
             </a:r>
           </a:p>
         </p:txBody>

</xml_diff>

<commit_message>
docs: prepare the NanoLang 5.1 release
</commit_message>
<xml_diff>
--- a/docs/presentation/nanolang-developer-overview.pptx
+++ b/docs/presentation/nanolang-developer-overview.pptx
@@ -997,17 +997,17 @@
           <a:lstStyle/>
           <a:p>
             <a:r>
-              <a:t>Authority: docs/RELEASE_5.0.md, docs/CALLBACK_ABI.md, docs/ROADMAP.md.</a:t>
-            </a:r>
-          </a:p>
-          <a:p>
-            <a:r>
-              <a:t>Retained adapters preserve callback lifetimes and owner-thread execution. Isolated imports cannot use this bridge.</a:t>
-            </a:r>
-          </a:p>
-          <a:p>
-            <a:r>
-              <a:t>My 2026-09-16 checkpoints cover native and VM effects. Exact-commit clean-tree tests, platform CI and release acceptance are mandatory release gates.</a:t>
+              <a:t>Authority: docs/RELEASE_5.1.md, docs/NANOISA_ONLY.md, docs/CALLBACK_ABI.md and docs/ROADMAP.md.</a:t>
+            </a:r>
+          </a:p>
+          <a:p>
+            <a:r>
+              <a:t>The fixed point compares raw Stage 1 and Stage 2 compiler modules; it does not prove compiler correctness.</a:t>
+            </a:r>
+          </a:p>
+          <a:p>
+            <a:r>
+              <a:t>Private non-admitting mixed record-array work remains outside the public product contract.</a:t>
             </a:r>
           </a:p>
         </p:txBody>
@@ -1227,7 +1227,12 @@
           <a:lstStyle/>
           <a:p>
             <a:r>
-              <a:t>Authority: docs/NANOISA.md and src/nanovirt/main.c.</a:t>
+              <a:t>Authority: docs/NANOISA_ONLY.md, src/nanovirt/main.c and src_nano/compiler/nanoisa_codegen.nano.</a:t>
+            </a:r>
+          </a:p>
+          <a:p>
+            <a:r>
+              <a:t>LLVM and Wasm are additional consumers of the same verified module; this slide keeps the main product path readable.</a:t>
             </a:r>
           </a:p>
         </p:txBody>
@@ -4852,7 +4857,7 @@
                 </a:solidFill>
                 <a:latin typeface="Arial"/>
               </a:rPr>
-              <a:t>NANOLANG 5.0</a:t>
+              <a:t>NANOLANG 5.1</a:t>
             </a:r>
           </a:p>
         </p:txBody>
@@ -8375,7 +8380,7 @@
                 </a:solidFill>
                 <a:latin typeface="Arial"/>
               </a:rPr>
-              <a:t>My 5.0 contract, and the work still ahead.</a:t>
+              <a:t>My 5.1 One IR contract, with boundaries intact.</a:t>
             </a:r>
           </a:p>
         </p:txBody>
@@ -8409,7 +8414,7 @@
                 </a:solidFill>
                 <a:latin typeface="Arial"/>
               </a:rPr>
-              <a:t>My language/runtime scope has explicit architecture limits.</a:t>
+              <a:t>I completed the product transition without turning private experiments into public authority.</a:t>
             </a:r>
           </a:p>
         </p:txBody>
@@ -8555,7 +8560,7 @@
                 </a:solidFill>
                 <a:latin typeface="Arial"/>
               </a:rPr>
-              <a:t>5.0 RELEASE SCOPE</a:t>
+              <a:t>5.1 RELEASE SCOPE</a:t>
             </a:r>
           </a:p>
         </p:txBody>
@@ -8589,7 +8594,7 @@
                 </a:solidFill>
                 <a:latin typeface="Arial"/>
               </a:rPr>
-              <a:t>enclosing-function return</a:t>
+              <a:t>verified .nvm default</a:t>
             </a:r>
           </a:p>
           <a:p>
@@ -8600,7 +8605,7 @@
                 </a:solidFill>
                 <a:latin typeface="Arial"/>
               </a:rPr>
-              <a:t>dependency shadows</a:t>
+              <a:t>raw compiler fixed point</a:t>
             </a:r>
           </a:p>
           <a:p>
@@ -8611,7 +8616,7 @@
                 </a:solidFill>
                 <a:latin typeface="Arial"/>
               </a:rPr>
-              <a:t>retained native callbacks</a:t>
+              <a:t>C11 / LLVM / Wasm</a:t>
             </a:r>
           </a:p>
           <a:p>
@@ -8622,7 +8627,7 @@
                 </a:solidFill>
                 <a:latin typeface="Arial"/>
               </a:rPr>
-              <a:t>module identity + caches</a:t>
+              <a:t>concrete union identity</a:t>
             </a:r>
           </a:p>
           <a:p>
@@ -8633,7 +8638,7 @@
                 </a:solidFill>
                 <a:latin typeface="Arial"/>
               </a:rPr>
-              <a:t>expanded native lowering</a:t>
+              <a:t>affine ownership facts</a:t>
             </a:r>
           </a:p>
           <a:p>
@@ -8644,7 +8649,7 @@
                 </a:solidFill>
                 <a:latin typeface="Arial"/>
               </a:rPr>
-              <a:t>laboratory frontends</a:t>
+              <a:t>lifetime-safe callbacks</a:t>
             </a:r>
           </a:p>
         </p:txBody>
@@ -8721,7 +8726,7 @@
                 </a:solidFill>
                 <a:latin typeface="Arial"/>
               </a:rPr>
-              <a:t>NOT DONE</a:t>
+              <a:t>EXPLICIT LIMITS</a:t>
             </a:r>
           </a:p>
         </p:txBody>
@@ -8755,7 +8760,7 @@
                 </a:solidFill>
                 <a:latin typeface="Arial"/>
               </a:rPr>
-              <a:t>NanoISA-only bootstrap</a:t>
+              <a:t>private mixed graphs</a:t>
             </a:r>
           </a:p>
           <a:p>
@@ -8766,7 +8771,7 @@
                 </a:solidFill>
                 <a:latin typeface="Arial"/>
               </a:rPr>
-              <a:t>matching compiler .nvm</a:t>
+              <a:t>conservative refusals</a:t>
             </a:r>
           </a:p>
           <a:p>
@@ -8777,7 +8782,7 @@
                 </a:solidFill>
                 <a:latin typeface="Arial"/>
               </a:rPr>
-              <a:t>full backend parity</a:t>
+              <a:t>no isolated callbacks</a:t>
             </a:r>
           </a:p>
           <a:p>
@@ -8788,7 +8793,7 @@
                 </a:solidFill>
                 <a:latin typeface="Arial"/>
               </a:rPr>
-              <a:t>complete ownership</a:t>
+              <a:t>formal core boundary</a:t>
             </a:r>
           </a:p>
           <a:p>
@@ -8799,7 +8804,7 @@
                 </a:solidFill>
                 <a:latin typeface="Arial"/>
               </a:rPr>
-              <a:t>isolated callback ABI</a:t>
+              <a:t>no kernel claim</a:t>
             </a:r>
           </a:p>
           <a:p>
@@ -8810,7 +8815,7 @@
                 </a:solidFill>
                 <a:latin typeface="Arial"/>
               </a:rPr>
-              <a:t>production isolation</a:t>
+              <a:t>no universal backend claim</a:t>
             </a:r>
           </a:p>
         </p:txBody>
@@ -9008,7 +9013,7 @@
                 </a:solidFill>
                 <a:latin typeface="Courier New"/>
               </a:rPr>
-              <a:t>docs/RELEASE_5.0.md · docs/CALLBACK_ABI.md</a:t>
+              <a:t>docs/RELEASE_5.1.md · docs/NANOISA_ONLY.md</a:t>
             </a:r>
           </a:p>
         </p:txBody>
@@ -9703,7 +9708,7 @@
                 </a:solidFill>
                 <a:latin typeface="Arial"/>
               </a:rPr>
-              <a:t>One source language, two execution paths.</a:t>
+              <a:t>One verified product, several consumers.</a:t>
             </a:r>
           </a:p>
         </p:txBody>
@@ -9737,7 +9742,7 @@
                 </a:solidFill>
                 <a:latin typeface="Arial"/>
               </a:rPr>
-              <a:t>The C path is my native baseline. NanoISA and NanoVM make the intermediate explicit.</a:t>
+              <a:t>Both frontends lower to NanoISA; execution and AOT begin from the same module.</a:t>
             </a:r>
           </a:p>
         </p:txBody>
@@ -9917,7 +9922,7 @@
                 </a:solidFill>
                 <a:latin typeface="Arial"/>
               </a:rPr>
-              <a:t>source + shadow tests</a:t>
+              <a:t>source + shadows</a:t>
             </a:r>
           </a:p>
         </p:txBody>
@@ -9990,7 +9995,7 @@
             <a:r>
               <a:rPr sz="1500" b="1">
                 <a:solidFill>
-                  <a:srgbClr val="72B7D6"/>
+                  <a:srgbClr val="76B900"/>
                 </a:solidFill>
                 <a:latin typeface="Courier New"/>
               </a:rPr>
@@ -10028,7 +10033,7 @@
                 </a:solidFill>
                 <a:latin typeface="Arial"/>
               </a:rPr>
-              <a:t>generated C</a:t>
+              <a:t>verified .nvm</a:t>
             </a:r>
           </a:p>
         </p:txBody>
@@ -10101,11 +10106,11 @@
             <a:r>
               <a:rPr sz="1500" b="1">
                 <a:solidFill>
-                  <a:srgbClr val="76B900"/>
+                  <a:srgbClr val="EEF1F3"/>
                 </a:solidFill>
                 <a:latin typeface="Courier New"/>
               </a:rPr>
-              <a:t>nano_virt</a:t>
+              <a:t>nano_vm</a:t>
             </a:r>
           </a:p>
         </p:txBody>
@@ -10139,7 +10144,7 @@
                 </a:solidFill>
                 <a:latin typeface="Arial"/>
               </a:rPr>
-              <a:t>NVM bytecode</a:t>
+              <a:t>direct execution</a:t>
             </a:r>
           </a:p>
         </p:txBody>
@@ -10212,11 +10217,11 @@
             <a:r>
               <a:rPr sz="1500" b="1">
                 <a:solidFill>
-                  <a:srgbClr val="EEF1F3"/>
+                  <a:srgbClr val="72B7D6"/>
                 </a:solidFill>
                 <a:latin typeface="Courier New"/>
               </a:rPr>
-              <a:t>nano_vm</a:t>
+              <a:t>nvm2c</a:t>
             </a:r>
           </a:p>
         </p:txBody>
@@ -10250,7 +10255,7 @@
                 </a:solidFill>
                 <a:latin typeface="Arial"/>
               </a:rPr>
-              <a:t>verified execution</a:t>
+              <a:t>C11 → native</a:t>
             </a:r>
           </a:p>
         </p:txBody>

</xml_diff>

<commit_message>
Qualify local 5.1 presentation claims and retain hosted enum leak evidence
</commit_message>
<xml_diff>
--- a/docs/presentation/nanolang-developer-overview.pptx
+++ b/docs/presentation/nanolang-developer-overview.pptx
@@ -517,7 +517,7 @@
           <a:lstStyle/>
           <a:p>
             <a:r>
-              <a:t>Authority: docs/PERSONA.md, README.md, docs/RELEASE_4.5.md.</a:t>
+              <a:t>Authority: docs/PERSONA.md, README.md, docs/RELEASE_5.1.md.</a:t>
             </a:r>
           </a:p>
           <a:p>
@@ -1002,7 +1002,7 @@
           </a:p>
           <a:p>
             <a:r>
-              <a:t>The fixed point compares raw Stage 1 and Stage 2 compiler modules; it does not prove compiler correctness.</a:t>
+              <a:t>The VM fixed point at 0eb94026c compares raw Stage 1 and Stage 2 modules. It does not prove compiler correctness. Final-source VM/native fixed points and complete hosted acceptance remain pending.</a:t>
             </a:r>
           </a:p>
           <a:p>
@@ -1077,7 +1077,7 @@
           <a:lstStyle/>
           <a:p>
             <a:r>
-              <a:t>Authority: CONTRIBUTING.md, docs/PERSONA.md, docs/ROADMAP.md, docs/RELEASE_4.5.md.</a:t>
+              <a:t>Authority: CONTRIBUTING.md, docs/PERSONA.md, docs/ROADMAP.md, docs/RELEASE_5.1.md.</a:t>
             </a:r>
           </a:p>
         </p:txBody>
@@ -4857,7 +4857,7 @@
                 </a:solidFill>
                 <a:latin typeface="Arial"/>
               </a:rPr>
-              <a:t>NANOLANG 5.1</a:t>
+              <a:t>NANOLANG 5.1 CANDIDATE</a:t>
             </a:r>
           </a:p>
         </p:txBody>
@@ -8414,7 +8414,7 @@
                 </a:solidFill>
                 <a:latin typeface="Arial"/>
               </a:rPr>
-              <a:t>I completed the product transition without turning private experiments into public authority.</a:t>
+              <a:t>My implementation has pinned evidence; final release qualification remains open.</a:t>
             </a:r>
           </a:p>
         </p:txBody>
@@ -8560,7 +8560,7 @@
                 </a:solidFill>
                 <a:latin typeface="Arial"/>
               </a:rPr>
-              <a:t>5.1 RELEASE SCOPE</a:t>
+              <a:t>5.1 CANDIDATE SCOPE</a:t>
             </a:r>
           </a:p>
         </p:txBody>

</xml_diff>